<commit_message>
Deployed 7dea45e with MkDocs version: 1.6.1
</commit_message>
<xml_diff>
--- a/CIEL/C107-Integration/C107-Integration_cours.pptx
+++ b/CIEL/C107-Integration/C107-Integration_cours.pptx
@@ -13,6 +13,7 @@
     <p:sldId id="261" r:id="rId7"/>
     <p:sldId id="262" r:id="rId8"/>
     <p:sldId id="263" r:id="rId9"/>
+    <p:sldId id="264" r:id="rId10"/>
   </p:sldIdLst>
   <p:sldSz cx="12192000" cy="6858000"/>
   <p:notesSz cx="6858000" cy="9144000"/>
@@ -3654,7 +3655,7 @@
           <a:p>
             <a:fld id="{BFF9F908-73B0-4296-89B5-9EEE89D79A9E}" type="datetimeFigureOut">
               <a:rPr lang="fr-FR" smtClean="0"/>
-              <a:t>09/03/2026</a:t>
+              <a:t>13/03/2026</a:t>
             </a:fld>
             <a:endParaRPr lang="fr-FR"/>
           </a:p>
@@ -3852,7 +3853,7 @@
           <a:p>
             <a:fld id="{BFF9F908-73B0-4296-89B5-9EEE89D79A9E}" type="datetimeFigureOut">
               <a:rPr lang="fr-FR" smtClean="0"/>
-              <a:t>09/03/2026</a:t>
+              <a:t>13/03/2026</a:t>
             </a:fld>
             <a:endParaRPr lang="fr-FR"/>
           </a:p>
@@ -4060,7 +4061,7 @@
           <a:p>
             <a:fld id="{BFF9F908-73B0-4296-89B5-9EEE89D79A9E}" type="datetimeFigureOut">
               <a:rPr lang="fr-FR" smtClean="0"/>
-              <a:t>09/03/2026</a:t>
+              <a:t>13/03/2026</a:t>
             </a:fld>
             <a:endParaRPr lang="fr-FR"/>
           </a:p>
@@ -4258,7 +4259,7 @@
           <a:p>
             <a:fld id="{BFF9F908-73B0-4296-89B5-9EEE89D79A9E}" type="datetimeFigureOut">
               <a:rPr lang="fr-FR" smtClean="0"/>
-              <a:t>09/03/2026</a:t>
+              <a:t>13/03/2026</a:t>
             </a:fld>
             <a:endParaRPr lang="fr-FR"/>
           </a:p>
@@ -4533,7 +4534,7 @@
           <a:p>
             <a:fld id="{BFF9F908-73B0-4296-89B5-9EEE89D79A9E}" type="datetimeFigureOut">
               <a:rPr lang="fr-FR" smtClean="0"/>
-              <a:t>09/03/2026</a:t>
+              <a:t>13/03/2026</a:t>
             </a:fld>
             <a:endParaRPr lang="fr-FR"/>
           </a:p>
@@ -4798,7 +4799,7 @@
           <a:p>
             <a:fld id="{BFF9F908-73B0-4296-89B5-9EEE89D79A9E}" type="datetimeFigureOut">
               <a:rPr lang="fr-FR" smtClean="0"/>
-              <a:t>09/03/2026</a:t>
+              <a:t>13/03/2026</a:t>
             </a:fld>
             <a:endParaRPr lang="fr-FR"/>
           </a:p>
@@ -5210,7 +5211,7 @@
           <a:p>
             <a:fld id="{BFF9F908-73B0-4296-89B5-9EEE89D79A9E}" type="datetimeFigureOut">
               <a:rPr lang="fr-FR" smtClean="0"/>
-              <a:t>09/03/2026</a:t>
+              <a:t>13/03/2026</a:t>
             </a:fld>
             <a:endParaRPr lang="fr-FR"/>
           </a:p>
@@ -5351,7 +5352,7 @@
           <a:p>
             <a:fld id="{BFF9F908-73B0-4296-89B5-9EEE89D79A9E}" type="datetimeFigureOut">
               <a:rPr lang="fr-FR" smtClean="0"/>
-              <a:t>09/03/2026</a:t>
+              <a:t>13/03/2026</a:t>
             </a:fld>
             <a:endParaRPr lang="fr-FR"/>
           </a:p>
@@ -5464,7 +5465,7 @@
           <a:p>
             <a:fld id="{BFF9F908-73B0-4296-89B5-9EEE89D79A9E}" type="datetimeFigureOut">
               <a:rPr lang="fr-FR" smtClean="0"/>
-              <a:t>09/03/2026</a:t>
+              <a:t>13/03/2026</a:t>
             </a:fld>
             <a:endParaRPr lang="fr-FR"/>
           </a:p>
@@ -5775,7 +5776,7 @@
           <a:p>
             <a:fld id="{BFF9F908-73B0-4296-89B5-9EEE89D79A9E}" type="datetimeFigureOut">
               <a:rPr lang="fr-FR" smtClean="0"/>
-              <a:t>09/03/2026</a:t>
+              <a:t>13/03/2026</a:t>
             </a:fld>
             <a:endParaRPr lang="fr-FR"/>
           </a:p>
@@ -6063,7 +6064,7 @@
           <a:p>
             <a:fld id="{BFF9F908-73B0-4296-89B5-9EEE89D79A9E}" type="datetimeFigureOut">
               <a:rPr lang="fr-FR" smtClean="0"/>
-              <a:t>09/03/2026</a:t>
+              <a:t>13/03/2026</a:t>
             </a:fld>
             <a:endParaRPr lang="fr-FR"/>
           </a:p>
@@ -6304,7 +6305,7 @@
           <a:p>
             <a:fld id="{BFF9F908-73B0-4296-89B5-9EEE89D79A9E}" type="datetimeFigureOut">
               <a:rPr lang="fr-FR" smtClean="0"/>
-              <a:t>09/03/2026</a:t>
+              <a:t>13/03/2026</a:t>
             </a:fld>
             <a:endParaRPr lang="fr-FR"/>
           </a:p>
@@ -6957,8 +6958,8 @@
           </a:prstGeom>
         </p:spPr>
       </p:pic>
-      <mc:AlternateContent xmlns:mc="http://schemas.openxmlformats.org/markup-compatibility/2006">
-        <mc:Choice xmlns:a14="http://schemas.microsoft.com/office/drawing/2010/main" Requires="a14">
+      <mc:AlternateContent xmlns:mc="http://schemas.openxmlformats.org/markup-compatibility/2006" xmlns:a14="http://schemas.microsoft.com/office/drawing/2010/main">
+        <mc:Choice Requires="a14">
           <p:sp>
             <p:nvSpPr>
               <p:cNvPr id="2" name="ZoneTexte 1">
@@ -7340,7 +7341,7 @@
             </p:txBody>
           </p:sp>
         </mc:Choice>
-        <mc:Fallback>
+        <mc:Fallback xmlns="">
           <p:sp>
             <p:nvSpPr>
               <p:cNvPr id="2" name="ZoneTexte 1">
@@ -7445,8 +7446,8 @@
           </a:prstGeom>
         </p:spPr>
       </p:pic>
-      <mc:AlternateContent xmlns:mc="http://schemas.openxmlformats.org/markup-compatibility/2006">
-        <mc:Choice xmlns:p14="http://schemas.microsoft.com/office/powerpoint/2010/main" Requires="p14">
+      <mc:AlternateContent xmlns:mc="http://schemas.openxmlformats.org/markup-compatibility/2006" xmlns:p14="http://schemas.microsoft.com/office/powerpoint/2010/main">
+        <mc:Choice Requires="p14">
           <p:contentPart p14:bwMode="auto" r:id="rId3">
             <p14:nvContentPartPr>
               <p14:cNvPr id="7" name="Encre 6">
@@ -7465,7 +7466,7 @@
             </p14:xfrm>
           </p:contentPart>
         </mc:Choice>
-        <mc:Fallback>
+        <mc:Fallback xmlns="">
           <p:pic>
             <p:nvPicPr>
               <p:cNvPr id="7" name="Encre 6">
@@ -7516,8 +7517,8 @@
             <a:chExt cx="1263600" cy="702000"/>
           </a:xfrm>
         </p:grpSpPr>
-        <mc:AlternateContent xmlns:mc="http://schemas.openxmlformats.org/markup-compatibility/2006">
-          <mc:Choice xmlns:p14="http://schemas.microsoft.com/office/powerpoint/2010/main" Requires="p14">
+        <mc:AlternateContent xmlns:mc="http://schemas.openxmlformats.org/markup-compatibility/2006" xmlns:p14="http://schemas.microsoft.com/office/powerpoint/2010/main">
+          <mc:Choice Requires="p14">
             <p:contentPart p14:bwMode="auto" r:id="rId5">
               <p14:nvContentPartPr>
                 <p14:cNvPr id="2" name="Encre 1">
@@ -7536,7 +7537,7 @@
               </p14:xfrm>
             </p:contentPart>
           </mc:Choice>
-          <mc:Fallback>
+          <mc:Fallback xmlns="">
             <p:pic>
               <p:nvPicPr>
                 <p:cNvPr id="2" name="Encre 1">
@@ -7567,8 +7568,8 @@
             </p:pic>
           </mc:Fallback>
         </mc:AlternateContent>
-        <mc:AlternateContent xmlns:mc="http://schemas.openxmlformats.org/markup-compatibility/2006">
-          <mc:Choice xmlns:p14="http://schemas.microsoft.com/office/powerpoint/2010/main" Requires="p14">
+        <mc:AlternateContent xmlns:mc="http://schemas.openxmlformats.org/markup-compatibility/2006" xmlns:p14="http://schemas.microsoft.com/office/powerpoint/2010/main">
+          <mc:Choice Requires="p14">
             <p:contentPart p14:bwMode="auto" r:id="rId7">
               <p14:nvContentPartPr>
                 <p14:cNvPr id="4" name="Encre 3">
@@ -7587,7 +7588,7 @@
               </p14:xfrm>
             </p:contentPart>
           </mc:Choice>
-          <mc:Fallback>
+          <mc:Fallback xmlns="">
             <p:pic>
               <p:nvPicPr>
                 <p:cNvPr id="4" name="Encre 3">
@@ -7618,8 +7619,8 @@
             </p:pic>
           </mc:Fallback>
         </mc:AlternateContent>
-        <mc:AlternateContent xmlns:mc="http://schemas.openxmlformats.org/markup-compatibility/2006">
-          <mc:Choice xmlns:p14="http://schemas.microsoft.com/office/powerpoint/2010/main" Requires="p14">
+        <mc:AlternateContent xmlns:mc="http://schemas.openxmlformats.org/markup-compatibility/2006" xmlns:p14="http://schemas.microsoft.com/office/powerpoint/2010/main">
+          <mc:Choice Requires="p14">
             <p:contentPart p14:bwMode="auto" r:id="rId9">
               <p14:nvContentPartPr>
                 <p14:cNvPr id="8" name="Encre 7">
@@ -7638,7 +7639,7 @@
               </p14:xfrm>
             </p:contentPart>
           </mc:Choice>
-          <mc:Fallback>
+          <mc:Fallback xmlns="">
             <p:pic>
               <p:nvPicPr>
                 <p:cNvPr id="8" name="Encre 7">
@@ -7669,8 +7670,8 @@
             </p:pic>
           </mc:Fallback>
         </mc:AlternateContent>
-        <mc:AlternateContent xmlns:mc="http://schemas.openxmlformats.org/markup-compatibility/2006">
-          <mc:Choice xmlns:p14="http://schemas.microsoft.com/office/powerpoint/2010/main" Requires="p14">
+        <mc:AlternateContent xmlns:mc="http://schemas.openxmlformats.org/markup-compatibility/2006" xmlns:p14="http://schemas.microsoft.com/office/powerpoint/2010/main">
+          <mc:Choice Requires="p14">
             <p:contentPart p14:bwMode="auto" r:id="rId11">
               <p14:nvContentPartPr>
                 <p14:cNvPr id="9" name="Encre 8">
@@ -7689,7 +7690,7 @@
               </p14:xfrm>
             </p:contentPart>
           </mc:Choice>
-          <mc:Fallback>
+          <mc:Fallback xmlns="">
             <p:pic>
               <p:nvPicPr>
                 <p:cNvPr id="9" name="Encre 8">
@@ -7720,8 +7721,8 @@
             </p:pic>
           </mc:Fallback>
         </mc:AlternateContent>
-        <mc:AlternateContent xmlns:mc="http://schemas.openxmlformats.org/markup-compatibility/2006">
-          <mc:Choice xmlns:p14="http://schemas.microsoft.com/office/powerpoint/2010/main" Requires="p14">
+        <mc:AlternateContent xmlns:mc="http://schemas.openxmlformats.org/markup-compatibility/2006" xmlns:p14="http://schemas.microsoft.com/office/powerpoint/2010/main">
+          <mc:Choice Requires="p14">
             <p:contentPart p14:bwMode="auto" r:id="rId13">
               <p14:nvContentPartPr>
                 <p14:cNvPr id="10" name="Encre 9">
@@ -7740,7 +7741,7 @@
               </p14:xfrm>
             </p:contentPart>
           </mc:Choice>
-          <mc:Fallback>
+          <mc:Fallback xmlns="">
             <p:pic>
               <p:nvPicPr>
                 <p:cNvPr id="10" name="Encre 9">
@@ -7771,8 +7772,8 @@
             </p:pic>
           </mc:Fallback>
         </mc:AlternateContent>
-        <mc:AlternateContent xmlns:mc="http://schemas.openxmlformats.org/markup-compatibility/2006">
-          <mc:Choice xmlns:p14="http://schemas.microsoft.com/office/powerpoint/2010/main" Requires="p14">
+        <mc:AlternateContent xmlns:mc="http://schemas.openxmlformats.org/markup-compatibility/2006" xmlns:p14="http://schemas.microsoft.com/office/powerpoint/2010/main">
+          <mc:Choice Requires="p14">
             <p:contentPart p14:bwMode="auto" r:id="rId15">
               <p14:nvContentPartPr>
                 <p14:cNvPr id="12" name="Encre 11">
@@ -7791,7 +7792,7 @@
               </p14:xfrm>
             </p:contentPart>
           </mc:Choice>
-          <mc:Fallback>
+          <mc:Fallback xmlns="">
             <p:pic>
               <p:nvPicPr>
                 <p:cNvPr id="12" name="Encre 11">
@@ -7822,8 +7823,8 @@
             </p:pic>
           </mc:Fallback>
         </mc:AlternateContent>
-        <mc:AlternateContent xmlns:mc="http://schemas.openxmlformats.org/markup-compatibility/2006">
-          <mc:Choice xmlns:p14="http://schemas.microsoft.com/office/powerpoint/2010/main" Requires="p14">
+        <mc:AlternateContent xmlns:mc="http://schemas.openxmlformats.org/markup-compatibility/2006" xmlns:p14="http://schemas.microsoft.com/office/powerpoint/2010/main">
+          <mc:Choice Requires="p14">
             <p:contentPart p14:bwMode="auto" r:id="rId17">
               <p14:nvContentPartPr>
                 <p14:cNvPr id="13" name="Encre 12">
@@ -7842,7 +7843,7 @@
               </p14:xfrm>
             </p:contentPart>
           </mc:Choice>
-          <mc:Fallback>
+          <mc:Fallback xmlns="">
             <p:pic>
               <p:nvPicPr>
                 <p:cNvPr id="13" name="Encre 12">
@@ -7873,8 +7874,8 @@
             </p:pic>
           </mc:Fallback>
         </mc:AlternateContent>
-        <mc:AlternateContent xmlns:mc="http://schemas.openxmlformats.org/markup-compatibility/2006">
-          <mc:Choice xmlns:p14="http://schemas.microsoft.com/office/powerpoint/2010/main" Requires="p14">
+        <mc:AlternateContent xmlns:mc="http://schemas.openxmlformats.org/markup-compatibility/2006" xmlns:p14="http://schemas.microsoft.com/office/powerpoint/2010/main">
+          <mc:Choice Requires="p14">
             <p:contentPart p14:bwMode="auto" r:id="rId19">
               <p14:nvContentPartPr>
                 <p14:cNvPr id="14" name="Encre 13">
@@ -7893,7 +7894,7 @@
               </p14:xfrm>
             </p:contentPart>
           </mc:Choice>
-          <mc:Fallback>
+          <mc:Fallback xmlns="">
             <p:pic>
               <p:nvPicPr>
                 <p:cNvPr id="14" name="Encre 13">
@@ -7924,8 +7925,8 @@
             </p:pic>
           </mc:Fallback>
         </mc:AlternateContent>
-        <mc:AlternateContent xmlns:mc="http://schemas.openxmlformats.org/markup-compatibility/2006">
-          <mc:Choice xmlns:p14="http://schemas.microsoft.com/office/powerpoint/2010/main" Requires="p14">
+        <mc:AlternateContent xmlns:mc="http://schemas.openxmlformats.org/markup-compatibility/2006" xmlns:p14="http://schemas.microsoft.com/office/powerpoint/2010/main">
+          <mc:Choice Requires="p14">
             <p:contentPart p14:bwMode="auto" r:id="rId21">
               <p14:nvContentPartPr>
                 <p14:cNvPr id="15" name="Encre 14">
@@ -7944,7 +7945,7 @@
               </p14:xfrm>
             </p:contentPart>
           </mc:Choice>
-          <mc:Fallback>
+          <mc:Fallback xmlns="">
             <p:pic>
               <p:nvPicPr>
                 <p:cNvPr id="15" name="Encre 14">
@@ -7975,8 +7976,8 @@
             </p:pic>
           </mc:Fallback>
         </mc:AlternateContent>
-        <mc:AlternateContent xmlns:mc="http://schemas.openxmlformats.org/markup-compatibility/2006">
-          <mc:Choice xmlns:p14="http://schemas.microsoft.com/office/powerpoint/2010/main" Requires="p14">
+        <mc:AlternateContent xmlns:mc="http://schemas.openxmlformats.org/markup-compatibility/2006" xmlns:p14="http://schemas.microsoft.com/office/powerpoint/2010/main">
+          <mc:Choice Requires="p14">
             <p:contentPart p14:bwMode="auto" r:id="rId23">
               <p14:nvContentPartPr>
                 <p14:cNvPr id="16" name="Encre 15">
@@ -7995,7 +7996,7 @@
               </p14:xfrm>
             </p:contentPart>
           </mc:Choice>
-          <mc:Fallback>
+          <mc:Fallback xmlns="">
             <p:pic>
               <p:nvPicPr>
                 <p:cNvPr id="16" name="Encre 15">
@@ -8026,8 +8027,8 @@
             </p:pic>
           </mc:Fallback>
         </mc:AlternateContent>
-        <mc:AlternateContent xmlns:mc="http://schemas.openxmlformats.org/markup-compatibility/2006">
-          <mc:Choice xmlns:p14="http://schemas.microsoft.com/office/powerpoint/2010/main" Requires="p14">
+        <mc:AlternateContent xmlns:mc="http://schemas.openxmlformats.org/markup-compatibility/2006" xmlns:p14="http://schemas.microsoft.com/office/powerpoint/2010/main">
+          <mc:Choice Requires="p14">
             <p:contentPart p14:bwMode="auto" r:id="rId25">
               <p14:nvContentPartPr>
                 <p14:cNvPr id="17" name="Encre 16">
@@ -8046,7 +8047,7 @@
               </p14:xfrm>
             </p:contentPart>
           </mc:Choice>
-          <mc:Fallback>
+          <mc:Fallback xmlns="">
             <p:pic>
               <p:nvPicPr>
                 <p:cNvPr id="17" name="Encre 16">
@@ -8077,8 +8078,8 @@
             </p:pic>
           </mc:Fallback>
         </mc:AlternateContent>
-        <mc:AlternateContent xmlns:mc="http://schemas.openxmlformats.org/markup-compatibility/2006">
-          <mc:Choice xmlns:p14="http://schemas.microsoft.com/office/powerpoint/2010/main" Requires="p14">
+        <mc:AlternateContent xmlns:mc="http://schemas.openxmlformats.org/markup-compatibility/2006" xmlns:p14="http://schemas.microsoft.com/office/powerpoint/2010/main">
+          <mc:Choice Requires="p14">
             <p:contentPart p14:bwMode="auto" r:id="rId27">
               <p14:nvContentPartPr>
                 <p14:cNvPr id="18" name="Encre 17">
@@ -8097,7 +8098,7 @@
               </p14:xfrm>
             </p:contentPart>
           </mc:Choice>
-          <mc:Fallback>
+          <mc:Fallback xmlns="">
             <p:pic>
               <p:nvPicPr>
                 <p:cNvPr id="18" name="Encre 17">
@@ -8128,8 +8129,8 @@
             </p:pic>
           </mc:Fallback>
         </mc:AlternateContent>
-        <mc:AlternateContent xmlns:mc="http://schemas.openxmlformats.org/markup-compatibility/2006">
-          <mc:Choice xmlns:p14="http://schemas.microsoft.com/office/powerpoint/2010/main" Requires="p14">
+        <mc:AlternateContent xmlns:mc="http://schemas.openxmlformats.org/markup-compatibility/2006" xmlns:p14="http://schemas.microsoft.com/office/powerpoint/2010/main">
+          <mc:Choice Requires="p14">
             <p:contentPart p14:bwMode="auto" r:id="rId29">
               <p14:nvContentPartPr>
                 <p14:cNvPr id="19" name="Encre 18">
@@ -8148,7 +8149,7 @@
               </p14:xfrm>
             </p:contentPart>
           </mc:Choice>
-          <mc:Fallback>
+          <mc:Fallback xmlns="">
             <p:pic>
               <p:nvPicPr>
                 <p:cNvPr id="19" name="Encre 18">
@@ -8179,8 +8180,8 @@
             </p:pic>
           </mc:Fallback>
         </mc:AlternateContent>
-        <mc:AlternateContent xmlns:mc="http://schemas.openxmlformats.org/markup-compatibility/2006">
-          <mc:Choice xmlns:p14="http://schemas.microsoft.com/office/powerpoint/2010/main" Requires="p14">
+        <mc:AlternateContent xmlns:mc="http://schemas.openxmlformats.org/markup-compatibility/2006" xmlns:p14="http://schemas.microsoft.com/office/powerpoint/2010/main">
+          <mc:Choice Requires="p14">
             <p:contentPart p14:bwMode="auto" r:id="rId31">
               <p14:nvContentPartPr>
                 <p14:cNvPr id="20" name="Encre 19">
@@ -8199,7 +8200,7 @@
               </p14:xfrm>
             </p:contentPart>
           </mc:Choice>
-          <mc:Fallback>
+          <mc:Fallback xmlns="">
             <p:pic>
               <p:nvPicPr>
                 <p:cNvPr id="20" name="Encre 19">
@@ -8230,8 +8231,8 @@
             </p:pic>
           </mc:Fallback>
         </mc:AlternateContent>
-        <mc:AlternateContent xmlns:mc="http://schemas.openxmlformats.org/markup-compatibility/2006">
-          <mc:Choice xmlns:p14="http://schemas.microsoft.com/office/powerpoint/2010/main" Requires="p14">
+        <mc:AlternateContent xmlns:mc="http://schemas.openxmlformats.org/markup-compatibility/2006" xmlns:p14="http://schemas.microsoft.com/office/powerpoint/2010/main">
+          <mc:Choice Requires="p14">
             <p:contentPart p14:bwMode="auto" r:id="rId33">
               <p14:nvContentPartPr>
                 <p14:cNvPr id="21" name="Encre 20">
@@ -8250,7 +8251,7 @@
               </p14:xfrm>
             </p:contentPart>
           </mc:Choice>
-          <mc:Fallback>
+          <mc:Fallback xmlns="">
             <p:pic>
               <p:nvPicPr>
                 <p:cNvPr id="21" name="Encre 20">
@@ -8281,8 +8282,8 @@
             </p:pic>
           </mc:Fallback>
         </mc:AlternateContent>
-        <mc:AlternateContent xmlns:mc="http://schemas.openxmlformats.org/markup-compatibility/2006">
-          <mc:Choice xmlns:p14="http://schemas.microsoft.com/office/powerpoint/2010/main" Requires="p14">
+        <mc:AlternateContent xmlns:mc="http://schemas.openxmlformats.org/markup-compatibility/2006" xmlns:p14="http://schemas.microsoft.com/office/powerpoint/2010/main">
+          <mc:Choice Requires="p14">
             <p:contentPart p14:bwMode="auto" r:id="rId35">
               <p14:nvContentPartPr>
                 <p14:cNvPr id="22" name="Encre 21">
@@ -8301,7 +8302,7 @@
               </p14:xfrm>
             </p:contentPart>
           </mc:Choice>
-          <mc:Fallback>
+          <mc:Fallback xmlns="">
             <p:pic>
               <p:nvPicPr>
                 <p:cNvPr id="22" name="Encre 21">
@@ -8332,8 +8333,8 @@
             </p:pic>
           </mc:Fallback>
         </mc:AlternateContent>
-        <mc:AlternateContent xmlns:mc="http://schemas.openxmlformats.org/markup-compatibility/2006">
-          <mc:Choice xmlns:p14="http://schemas.microsoft.com/office/powerpoint/2010/main" Requires="p14">
+        <mc:AlternateContent xmlns:mc="http://schemas.openxmlformats.org/markup-compatibility/2006" xmlns:p14="http://schemas.microsoft.com/office/powerpoint/2010/main">
+          <mc:Choice Requires="p14">
             <p:contentPart p14:bwMode="auto" r:id="rId37">
               <p14:nvContentPartPr>
                 <p14:cNvPr id="23" name="Encre 22">
@@ -8352,7 +8353,7 @@
               </p14:xfrm>
             </p:contentPart>
           </mc:Choice>
-          <mc:Fallback>
+          <mc:Fallback xmlns="">
             <p:pic>
               <p:nvPicPr>
                 <p:cNvPr id="23" name="Encre 22">
@@ -8383,8 +8384,8 @@
             </p:pic>
           </mc:Fallback>
         </mc:AlternateContent>
-        <mc:AlternateContent xmlns:mc="http://schemas.openxmlformats.org/markup-compatibility/2006">
-          <mc:Choice xmlns:p14="http://schemas.microsoft.com/office/powerpoint/2010/main" Requires="p14">
+        <mc:AlternateContent xmlns:mc="http://schemas.openxmlformats.org/markup-compatibility/2006" xmlns:p14="http://schemas.microsoft.com/office/powerpoint/2010/main">
+          <mc:Choice Requires="p14">
             <p:contentPart p14:bwMode="auto" r:id="rId39">
               <p14:nvContentPartPr>
                 <p14:cNvPr id="24" name="Encre 23">
@@ -8403,7 +8404,7 @@
               </p14:xfrm>
             </p:contentPart>
           </mc:Choice>
-          <mc:Fallback>
+          <mc:Fallback xmlns="">
             <p:pic>
               <p:nvPicPr>
                 <p:cNvPr id="24" name="Encre 23">
@@ -8434,8 +8435,8 @@
             </p:pic>
           </mc:Fallback>
         </mc:AlternateContent>
-        <mc:AlternateContent xmlns:mc="http://schemas.openxmlformats.org/markup-compatibility/2006">
-          <mc:Choice xmlns:p14="http://schemas.microsoft.com/office/powerpoint/2010/main" Requires="p14">
+        <mc:AlternateContent xmlns:mc="http://schemas.openxmlformats.org/markup-compatibility/2006" xmlns:p14="http://schemas.microsoft.com/office/powerpoint/2010/main">
+          <mc:Choice Requires="p14">
             <p:contentPart p14:bwMode="auto" r:id="rId41">
               <p14:nvContentPartPr>
                 <p14:cNvPr id="25" name="Encre 24">
@@ -8454,7 +8455,7 @@
               </p14:xfrm>
             </p:contentPart>
           </mc:Choice>
-          <mc:Fallback>
+          <mc:Fallback xmlns="">
             <p:pic>
               <p:nvPicPr>
                 <p:cNvPr id="25" name="Encre 24">
@@ -8485,8 +8486,8 @@
             </p:pic>
           </mc:Fallback>
         </mc:AlternateContent>
-        <mc:AlternateContent xmlns:mc="http://schemas.openxmlformats.org/markup-compatibility/2006">
-          <mc:Choice xmlns:p14="http://schemas.microsoft.com/office/powerpoint/2010/main" Requires="p14">
+        <mc:AlternateContent xmlns:mc="http://schemas.openxmlformats.org/markup-compatibility/2006" xmlns:p14="http://schemas.microsoft.com/office/powerpoint/2010/main">
+          <mc:Choice Requires="p14">
             <p:contentPart p14:bwMode="auto" r:id="rId43">
               <p14:nvContentPartPr>
                 <p14:cNvPr id="26" name="Encre 25">
@@ -8505,7 +8506,7 @@
               </p14:xfrm>
             </p:contentPart>
           </mc:Choice>
-          <mc:Fallback>
+          <mc:Fallback xmlns="">
             <p:pic>
               <p:nvPicPr>
                 <p:cNvPr id="26" name="Encre 25">
@@ -8536,8 +8537,8 @@
             </p:pic>
           </mc:Fallback>
         </mc:AlternateContent>
-        <mc:AlternateContent xmlns:mc="http://schemas.openxmlformats.org/markup-compatibility/2006">
-          <mc:Choice xmlns:p14="http://schemas.microsoft.com/office/powerpoint/2010/main" Requires="p14">
+        <mc:AlternateContent xmlns:mc="http://schemas.openxmlformats.org/markup-compatibility/2006" xmlns:p14="http://schemas.microsoft.com/office/powerpoint/2010/main">
+          <mc:Choice Requires="p14">
             <p:contentPart p14:bwMode="auto" r:id="rId45">
               <p14:nvContentPartPr>
                 <p14:cNvPr id="27" name="Encre 26">
@@ -8556,7 +8557,7 @@
               </p14:xfrm>
             </p:contentPart>
           </mc:Choice>
-          <mc:Fallback>
+          <mc:Fallback xmlns="">
             <p:pic>
               <p:nvPicPr>
                 <p:cNvPr id="27" name="Encre 26">
@@ -8587,8 +8588,8 @@
             </p:pic>
           </mc:Fallback>
         </mc:AlternateContent>
-        <mc:AlternateContent xmlns:mc="http://schemas.openxmlformats.org/markup-compatibility/2006">
-          <mc:Choice xmlns:p14="http://schemas.microsoft.com/office/powerpoint/2010/main" Requires="p14">
+        <mc:AlternateContent xmlns:mc="http://schemas.openxmlformats.org/markup-compatibility/2006" xmlns:p14="http://schemas.microsoft.com/office/powerpoint/2010/main">
+          <mc:Choice Requires="p14">
             <p:contentPart p14:bwMode="auto" r:id="rId47">
               <p14:nvContentPartPr>
                 <p14:cNvPr id="28" name="Encre 27">
@@ -8607,7 +8608,7 @@
               </p14:xfrm>
             </p:contentPart>
           </mc:Choice>
-          <mc:Fallback>
+          <mc:Fallback xmlns="">
             <p:pic>
               <p:nvPicPr>
                 <p:cNvPr id="28" name="Encre 27">
@@ -8638,8 +8639,8 @@
             </p:pic>
           </mc:Fallback>
         </mc:AlternateContent>
-        <mc:AlternateContent xmlns:mc="http://schemas.openxmlformats.org/markup-compatibility/2006">
-          <mc:Choice xmlns:p14="http://schemas.microsoft.com/office/powerpoint/2010/main" Requires="p14">
+        <mc:AlternateContent xmlns:mc="http://schemas.openxmlformats.org/markup-compatibility/2006" xmlns:p14="http://schemas.microsoft.com/office/powerpoint/2010/main">
+          <mc:Choice Requires="p14">
             <p:contentPart p14:bwMode="auto" r:id="rId49">
               <p14:nvContentPartPr>
                 <p14:cNvPr id="29" name="Encre 28">
@@ -8658,7 +8659,7 @@
               </p14:xfrm>
             </p:contentPart>
           </mc:Choice>
-          <mc:Fallback>
+          <mc:Fallback xmlns="">
             <p:pic>
               <p:nvPicPr>
                 <p:cNvPr id="29" name="Encre 28">
@@ -8710,8 +8711,8 @@
             <a:chExt cx="488880" cy="171360"/>
           </a:xfrm>
         </p:grpSpPr>
-        <mc:AlternateContent xmlns:mc="http://schemas.openxmlformats.org/markup-compatibility/2006">
-          <mc:Choice xmlns:p14="http://schemas.microsoft.com/office/powerpoint/2010/main" Requires="p14">
+        <mc:AlternateContent xmlns:mc="http://schemas.openxmlformats.org/markup-compatibility/2006" xmlns:p14="http://schemas.microsoft.com/office/powerpoint/2010/main">
+          <mc:Choice Requires="p14">
             <p:contentPart p14:bwMode="auto" r:id="rId51">
               <p14:nvContentPartPr>
                 <p14:cNvPr id="31" name="Encre 30">
@@ -8730,7 +8731,7 @@
               </p14:xfrm>
             </p:contentPart>
           </mc:Choice>
-          <mc:Fallback>
+          <mc:Fallback xmlns="">
             <p:pic>
               <p:nvPicPr>
                 <p:cNvPr id="31" name="Encre 30">
@@ -8761,8 +8762,8 @@
             </p:pic>
           </mc:Fallback>
         </mc:AlternateContent>
-        <mc:AlternateContent xmlns:mc="http://schemas.openxmlformats.org/markup-compatibility/2006">
-          <mc:Choice xmlns:p14="http://schemas.microsoft.com/office/powerpoint/2010/main" Requires="p14">
+        <mc:AlternateContent xmlns:mc="http://schemas.openxmlformats.org/markup-compatibility/2006" xmlns:p14="http://schemas.microsoft.com/office/powerpoint/2010/main">
+          <mc:Choice Requires="p14">
             <p:contentPart p14:bwMode="auto" r:id="rId53">
               <p14:nvContentPartPr>
                 <p14:cNvPr id="32" name="Encre 31">
@@ -8781,7 +8782,7 @@
               </p14:xfrm>
             </p:contentPart>
           </mc:Choice>
-          <mc:Fallback>
+          <mc:Fallback xmlns="">
             <p:pic>
               <p:nvPicPr>
                 <p:cNvPr id="32" name="Encre 31">
@@ -8812,8 +8813,8 @@
             </p:pic>
           </mc:Fallback>
         </mc:AlternateContent>
-        <mc:AlternateContent xmlns:mc="http://schemas.openxmlformats.org/markup-compatibility/2006">
-          <mc:Choice xmlns:p14="http://schemas.microsoft.com/office/powerpoint/2010/main" Requires="p14">
+        <mc:AlternateContent xmlns:mc="http://schemas.openxmlformats.org/markup-compatibility/2006" xmlns:p14="http://schemas.microsoft.com/office/powerpoint/2010/main">
+          <mc:Choice Requires="p14">
             <p:contentPart p14:bwMode="auto" r:id="rId55">
               <p14:nvContentPartPr>
                 <p14:cNvPr id="33" name="Encre 32">
@@ -8832,7 +8833,7 @@
               </p14:xfrm>
             </p:contentPart>
           </mc:Choice>
-          <mc:Fallback>
+          <mc:Fallback xmlns="">
             <p:pic>
               <p:nvPicPr>
                 <p:cNvPr id="33" name="Encre 32">
@@ -8863,8 +8864,8 @@
             </p:pic>
           </mc:Fallback>
         </mc:AlternateContent>
-        <mc:AlternateContent xmlns:mc="http://schemas.openxmlformats.org/markup-compatibility/2006">
-          <mc:Choice xmlns:p14="http://schemas.microsoft.com/office/powerpoint/2010/main" Requires="p14">
+        <mc:AlternateContent xmlns:mc="http://schemas.openxmlformats.org/markup-compatibility/2006" xmlns:p14="http://schemas.microsoft.com/office/powerpoint/2010/main">
+          <mc:Choice Requires="p14">
             <p:contentPart p14:bwMode="auto" r:id="rId57">
               <p14:nvContentPartPr>
                 <p14:cNvPr id="35" name="Encre 34">
@@ -8883,7 +8884,7 @@
               </p14:xfrm>
             </p:contentPart>
           </mc:Choice>
-          <mc:Fallback>
+          <mc:Fallback xmlns="">
             <p:pic>
               <p:nvPicPr>
                 <p:cNvPr id="35" name="Encre 34">
@@ -8915,8 +8916,8 @@
           </mc:Fallback>
         </mc:AlternateContent>
       </p:grpSp>
-      <mc:AlternateContent xmlns:mc="http://schemas.openxmlformats.org/markup-compatibility/2006">
-        <mc:Choice xmlns:p14="http://schemas.microsoft.com/office/powerpoint/2010/main" Requires="p14">
+      <mc:AlternateContent xmlns:mc="http://schemas.openxmlformats.org/markup-compatibility/2006" xmlns:p14="http://schemas.microsoft.com/office/powerpoint/2010/main">
+        <mc:Choice Requires="p14">
           <p:contentPart p14:bwMode="auto" r:id="rId59">
             <p14:nvContentPartPr>
               <p14:cNvPr id="37" name="Encre 36">
@@ -8935,7 +8936,7 @@
             </p14:xfrm>
           </p:contentPart>
         </mc:Choice>
-        <mc:Fallback>
+        <mc:Fallback xmlns="">
           <p:pic>
             <p:nvPicPr>
               <p:cNvPr id="37" name="Encre 36">
@@ -8966,8 +8967,8 @@
           </p:pic>
         </mc:Fallback>
       </mc:AlternateContent>
-      <mc:AlternateContent xmlns:mc="http://schemas.openxmlformats.org/markup-compatibility/2006">
-        <mc:Choice xmlns:p14="http://schemas.microsoft.com/office/powerpoint/2010/main" Requires="p14">
+      <mc:AlternateContent xmlns:mc="http://schemas.openxmlformats.org/markup-compatibility/2006" xmlns:p14="http://schemas.microsoft.com/office/powerpoint/2010/main">
+        <mc:Choice Requires="p14">
           <p:contentPart p14:bwMode="auto" r:id="rId61">
             <p14:nvContentPartPr>
               <p14:cNvPr id="38" name="Encre 37">
@@ -8986,7 +8987,7 @@
             </p14:xfrm>
           </p:contentPart>
         </mc:Choice>
-        <mc:Fallback>
+        <mc:Fallback xmlns="">
           <p:pic>
             <p:nvPicPr>
               <p:cNvPr id="38" name="Encre 37">
@@ -9017,8 +9018,8 @@
           </p:pic>
         </mc:Fallback>
       </mc:AlternateContent>
-      <mc:AlternateContent xmlns:mc="http://schemas.openxmlformats.org/markup-compatibility/2006">
-        <mc:Choice xmlns:p14="http://schemas.microsoft.com/office/powerpoint/2010/main" Requires="p14">
+      <mc:AlternateContent xmlns:mc="http://schemas.openxmlformats.org/markup-compatibility/2006" xmlns:p14="http://schemas.microsoft.com/office/powerpoint/2010/main">
+        <mc:Choice Requires="p14">
           <p:contentPart p14:bwMode="auto" r:id="rId63">
             <p14:nvContentPartPr>
               <p14:cNvPr id="39" name="Encre 38">
@@ -9037,7 +9038,7 @@
             </p14:xfrm>
           </p:contentPart>
         </mc:Choice>
-        <mc:Fallback>
+        <mc:Fallback xmlns="">
           <p:pic>
             <p:nvPicPr>
               <p:cNvPr id="39" name="Encre 38">
@@ -9088,8 +9089,8 @@
             <a:chExt cx="1300320" cy="1045080"/>
           </a:xfrm>
         </p:grpSpPr>
-        <mc:AlternateContent xmlns:mc="http://schemas.openxmlformats.org/markup-compatibility/2006">
-          <mc:Choice xmlns:p14="http://schemas.microsoft.com/office/powerpoint/2010/main" Requires="p14">
+        <mc:AlternateContent xmlns:mc="http://schemas.openxmlformats.org/markup-compatibility/2006" xmlns:p14="http://schemas.microsoft.com/office/powerpoint/2010/main">
+          <mc:Choice Requires="p14">
             <p:contentPart p14:bwMode="auto" r:id="rId65">
               <p14:nvContentPartPr>
                 <p14:cNvPr id="40" name="Encre 39">
@@ -9108,7 +9109,7 @@
               </p14:xfrm>
             </p:contentPart>
           </mc:Choice>
-          <mc:Fallback>
+          <mc:Fallback xmlns="">
             <p:pic>
               <p:nvPicPr>
                 <p:cNvPr id="40" name="Encre 39">
@@ -9139,8 +9140,8 @@
             </p:pic>
           </mc:Fallback>
         </mc:AlternateContent>
-        <mc:AlternateContent xmlns:mc="http://schemas.openxmlformats.org/markup-compatibility/2006">
-          <mc:Choice xmlns:p14="http://schemas.microsoft.com/office/powerpoint/2010/main" Requires="p14">
+        <mc:AlternateContent xmlns:mc="http://schemas.openxmlformats.org/markup-compatibility/2006" xmlns:p14="http://schemas.microsoft.com/office/powerpoint/2010/main">
+          <mc:Choice Requires="p14">
             <p:contentPart p14:bwMode="auto" r:id="rId67">
               <p14:nvContentPartPr>
                 <p14:cNvPr id="41" name="Encre 40">
@@ -9159,7 +9160,7 @@
               </p14:xfrm>
             </p:contentPart>
           </mc:Choice>
-          <mc:Fallback>
+          <mc:Fallback xmlns="">
             <p:pic>
               <p:nvPicPr>
                 <p:cNvPr id="41" name="Encre 40">
@@ -9190,8 +9191,8 @@
             </p:pic>
           </mc:Fallback>
         </mc:AlternateContent>
-        <mc:AlternateContent xmlns:mc="http://schemas.openxmlformats.org/markup-compatibility/2006">
-          <mc:Choice xmlns:p14="http://schemas.microsoft.com/office/powerpoint/2010/main" Requires="p14">
+        <mc:AlternateContent xmlns:mc="http://schemas.openxmlformats.org/markup-compatibility/2006" xmlns:p14="http://schemas.microsoft.com/office/powerpoint/2010/main">
+          <mc:Choice Requires="p14">
             <p:contentPart p14:bwMode="auto" r:id="rId69">
               <p14:nvContentPartPr>
                 <p14:cNvPr id="42" name="Encre 41">
@@ -9210,7 +9211,7 @@
               </p14:xfrm>
             </p:contentPart>
           </mc:Choice>
-          <mc:Fallback>
+          <mc:Fallback xmlns="">
             <p:pic>
               <p:nvPicPr>
                 <p:cNvPr id="42" name="Encre 41">
@@ -9262,8 +9263,8 @@
             <a:chExt cx="463680" cy="143640"/>
           </a:xfrm>
         </p:grpSpPr>
-        <mc:AlternateContent xmlns:mc="http://schemas.openxmlformats.org/markup-compatibility/2006">
-          <mc:Choice xmlns:p14="http://schemas.microsoft.com/office/powerpoint/2010/main" Requires="p14">
+        <mc:AlternateContent xmlns:mc="http://schemas.openxmlformats.org/markup-compatibility/2006" xmlns:p14="http://schemas.microsoft.com/office/powerpoint/2010/main">
+          <mc:Choice Requires="p14">
             <p:contentPart p14:bwMode="auto" r:id="rId71">
               <p14:nvContentPartPr>
                 <p14:cNvPr id="44" name="Encre 43">
@@ -9282,7 +9283,7 @@
               </p14:xfrm>
             </p:contentPart>
           </mc:Choice>
-          <mc:Fallback>
+          <mc:Fallback xmlns="">
             <p:pic>
               <p:nvPicPr>
                 <p:cNvPr id="44" name="Encre 43">
@@ -9313,8 +9314,8 @@
             </p:pic>
           </mc:Fallback>
         </mc:AlternateContent>
-        <mc:AlternateContent xmlns:mc="http://schemas.openxmlformats.org/markup-compatibility/2006">
-          <mc:Choice xmlns:p14="http://schemas.microsoft.com/office/powerpoint/2010/main" Requires="p14">
+        <mc:AlternateContent xmlns:mc="http://schemas.openxmlformats.org/markup-compatibility/2006" xmlns:p14="http://schemas.microsoft.com/office/powerpoint/2010/main">
+          <mc:Choice Requires="p14">
             <p:contentPart p14:bwMode="auto" r:id="rId73">
               <p14:nvContentPartPr>
                 <p14:cNvPr id="45" name="Encre 44">
@@ -9333,7 +9334,7 @@
               </p14:xfrm>
             </p:contentPart>
           </mc:Choice>
-          <mc:Fallback>
+          <mc:Fallback xmlns="">
             <p:pic>
               <p:nvPicPr>
                 <p:cNvPr id="45" name="Encre 44">
@@ -9416,8 +9417,8 @@
             <a:chExt cx="1442520" cy="1159560"/>
           </a:xfrm>
         </p:grpSpPr>
-        <mc:AlternateContent xmlns:mc="http://schemas.openxmlformats.org/markup-compatibility/2006">
-          <mc:Choice xmlns:p14="http://schemas.microsoft.com/office/powerpoint/2010/main" Requires="p14">
+        <mc:AlternateContent xmlns:mc="http://schemas.openxmlformats.org/markup-compatibility/2006" xmlns:p14="http://schemas.microsoft.com/office/powerpoint/2010/main">
+          <mc:Choice Requires="p14">
             <p:contentPart p14:bwMode="auto" r:id="rId75">
               <p14:nvContentPartPr>
                 <p14:cNvPr id="64" name="Encre 63">
@@ -9436,7 +9437,7 @@
               </p14:xfrm>
             </p:contentPart>
           </mc:Choice>
-          <mc:Fallback>
+          <mc:Fallback xmlns="">
             <p:pic>
               <p:nvPicPr>
                 <p:cNvPr id="64" name="Encre 63">
@@ -9467,8 +9468,8 @@
             </p:pic>
           </mc:Fallback>
         </mc:AlternateContent>
-        <mc:AlternateContent xmlns:mc="http://schemas.openxmlformats.org/markup-compatibility/2006">
-          <mc:Choice xmlns:p14="http://schemas.microsoft.com/office/powerpoint/2010/main" Requires="p14">
+        <mc:AlternateContent xmlns:mc="http://schemas.openxmlformats.org/markup-compatibility/2006" xmlns:p14="http://schemas.microsoft.com/office/powerpoint/2010/main">
+          <mc:Choice Requires="p14">
             <p:contentPart p14:bwMode="auto" r:id="rId77">
               <p14:nvContentPartPr>
                 <p14:cNvPr id="65" name="Encre 64">
@@ -9487,7 +9488,7 @@
               </p14:xfrm>
             </p:contentPart>
           </mc:Choice>
-          <mc:Fallback>
+          <mc:Fallback xmlns="">
             <p:pic>
               <p:nvPicPr>
                 <p:cNvPr id="65" name="Encre 64">
@@ -9518,8 +9519,8 @@
             </p:pic>
           </mc:Fallback>
         </mc:AlternateContent>
-        <mc:AlternateContent xmlns:mc="http://schemas.openxmlformats.org/markup-compatibility/2006">
-          <mc:Choice xmlns:p14="http://schemas.microsoft.com/office/powerpoint/2010/main" Requires="p14">
+        <mc:AlternateContent xmlns:mc="http://schemas.openxmlformats.org/markup-compatibility/2006" xmlns:p14="http://schemas.microsoft.com/office/powerpoint/2010/main">
+          <mc:Choice Requires="p14">
             <p:contentPart p14:bwMode="auto" r:id="rId79">
               <p14:nvContentPartPr>
                 <p14:cNvPr id="66" name="Encre 65">
@@ -9538,7 +9539,7 @@
               </p14:xfrm>
             </p:contentPart>
           </mc:Choice>
-          <mc:Fallback>
+          <mc:Fallback xmlns="">
             <p:pic>
               <p:nvPicPr>
                 <p:cNvPr id="66" name="Encre 65">
@@ -9569,8 +9570,8 @@
             </p:pic>
           </mc:Fallback>
         </mc:AlternateContent>
-        <mc:AlternateContent xmlns:mc="http://schemas.openxmlformats.org/markup-compatibility/2006">
-          <mc:Choice xmlns:p14="http://schemas.microsoft.com/office/powerpoint/2010/main" Requires="p14">
+        <mc:AlternateContent xmlns:mc="http://schemas.openxmlformats.org/markup-compatibility/2006" xmlns:p14="http://schemas.microsoft.com/office/powerpoint/2010/main">
+          <mc:Choice Requires="p14">
             <p:contentPart p14:bwMode="auto" r:id="rId81">
               <p14:nvContentPartPr>
                 <p14:cNvPr id="67" name="Encre 66">
@@ -9589,7 +9590,7 @@
               </p14:xfrm>
             </p:contentPart>
           </mc:Choice>
-          <mc:Fallback>
+          <mc:Fallback xmlns="">
             <p:pic>
               <p:nvPicPr>
                 <p:cNvPr id="67" name="Encre 66">
@@ -9620,8 +9621,8 @@
             </p:pic>
           </mc:Fallback>
         </mc:AlternateContent>
-        <mc:AlternateContent xmlns:mc="http://schemas.openxmlformats.org/markup-compatibility/2006">
-          <mc:Choice xmlns:p14="http://schemas.microsoft.com/office/powerpoint/2010/main" Requires="p14">
+        <mc:AlternateContent xmlns:mc="http://schemas.openxmlformats.org/markup-compatibility/2006" xmlns:p14="http://schemas.microsoft.com/office/powerpoint/2010/main">
+          <mc:Choice Requires="p14">
             <p:contentPart p14:bwMode="auto" r:id="rId83">
               <p14:nvContentPartPr>
                 <p14:cNvPr id="68" name="Encre 67">
@@ -9640,7 +9641,7 @@
               </p14:xfrm>
             </p:contentPart>
           </mc:Choice>
-          <mc:Fallback>
+          <mc:Fallback xmlns="">
             <p:pic>
               <p:nvPicPr>
                 <p:cNvPr id="68" name="Encre 67">
@@ -9671,8 +9672,8 @@
             </p:pic>
           </mc:Fallback>
         </mc:AlternateContent>
-        <mc:AlternateContent xmlns:mc="http://schemas.openxmlformats.org/markup-compatibility/2006">
-          <mc:Choice xmlns:p14="http://schemas.microsoft.com/office/powerpoint/2010/main" Requires="p14">
+        <mc:AlternateContent xmlns:mc="http://schemas.openxmlformats.org/markup-compatibility/2006" xmlns:p14="http://schemas.microsoft.com/office/powerpoint/2010/main">
+          <mc:Choice Requires="p14">
             <p:contentPart p14:bwMode="auto" r:id="rId85">
               <p14:nvContentPartPr>
                 <p14:cNvPr id="70" name="Encre 69">
@@ -9691,7 +9692,7 @@
               </p14:xfrm>
             </p:contentPart>
           </mc:Choice>
-          <mc:Fallback>
+          <mc:Fallback xmlns="">
             <p:pic>
               <p:nvPicPr>
                 <p:cNvPr id="70" name="Encre 69">
@@ -9722,8 +9723,8 @@
             </p:pic>
           </mc:Fallback>
         </mc:AlternateContent>
-        <mc:AlternateContent xmlns:mc="http://schemas.openxmlformats.org/markup-compatibility/2006">
-          <mc:Choice xmlns:p14="http://schemas.microsoft.com/office/powerpoint/2010/main" Requires="p14">
+        <mc:AlternateContent xmlns:mc="http://schemas.openxmlformats.org/markup-compatibility/2006" xmlns:p14="http://schemas.microsoft.com/office/powerpoint/2010/main">
+          <mc:Choice Requires="p14">
             <p:contentPart p14:bwMode="auto" r:id="rId87">
               <p14:nvContentPartPr>
                 <p14:cNvPr id="71" name="Encre 70">
@@ -9742,7 +9743,7 @@
               </p14:xfrm>
             </p:contentPart>
           </mc:Choice>
-          <mc:Fallback>
+          <mc:Fallback xmlns="">
             <p:pic>
               <p:nvPicPr>
                 <p:cNvPr id="71" name="Encre 70">
@@ -9773,8 +9774,8 @@
             </p:pic>
           </mc:Fallback>
         </mc:AlternateContent>
-        <mc:AlternateContent xmlns:mc="http://schemas.openxmlformats.org/markup-compatibility/2006">
-          <mc:Choice xmlns:p14="http://schemas.microsoft.com/office/powerpoint/2010/main" Requires="p14">
+        <mc:AlternateContent xmlns:mc="http://schemas.openxmlformats.org/markup-compatibility/2006" xmlns:p14="http://schemas.microsoft.com/office/powerpoint/2010/main">
+          <mc:Choice Requires="p14">
             <p:contentPart p14:bwMode="auto" r:id="rId88">
               <p14:nvContentPartPr>
                 <p14:cNvPr id="75" name="Encre 74">
@@ -9793,7 +9794,7 @@
               </p14:xfrm>
             </p:contentPart>
           </mc:Choice>
-          <mc:Fallback>
+          <mc:Fallback xmlns="">
             <p:pic>
               <p:nvPicPr>
                 <p:cNvPr id="75" name="Encre 74">
@@ -9824,8 +9825,8 @@
             </p:pic>
           </mc:Fallback>
         </mc:AlternateContent>
-        <mc:AlternateContent xmlns:mc="http://schemas.openxmlformats.org/markup-compatibility/2006">
-          <mc:Choice xmlns:p14="http://schemas.microsoft.com/office/powerpoint/2010/main" Requires="p14">
+        <mc:AlternateContent xmlns:mc="http://schemas.openxmlformats.org/markup-compatibility/2006" xmlns:p14="http://schemas.microsoft.com/office/powerpoint/2010/main">
+          <mc:Choice Requires="p14">
             <p:contentPart p14:bwMode="auto" r:id="rId90">
               <p14:nvContentPartPr>
                 <p14:cNvPr id="69" name="Encre 68">
@@ -9844,7 +9845,7 @@
               </p14:xfrm>
             </p:contentPart>
           </mc:Choice>
-          <mc:Fallback>
+          <mc:Fallback xmlns="">
             <p:pic>
               <p:nvPicPr>
                 <p:cNvPr id="69" name="Encre 68">
@@ -9875,8 +9876,8 @@
             </p:pic>
           </mc:Fallback>
         </mc:AlternateContent>
-        <mc:AlternateContent xmlns:mc="http://schemas.openxmlformats.org/markup-compatibility/2006">
-          <mc:Choice xmlns:p14="http://schemas.microsoft.com/office/powerpoint/2010/main" Requires="p14">
+        <mc:AlternateContent xmlns:mc="http://schemas.openxmlformats.org/markup-compatibility/2006" xmlns:p14="http://schemas.microsoft.com/office/powerpoint/2010/main">
+          <mc:Choice Requires="p14">
             <p:contentPart p14:bwMode="auto" r:id="rId92">
               <p14:nvContentPartPr>
                 <p14:cNvPr id="76" name="Encre 75">
@@ -9895,7 +9896,7 @@
               </p14:xfrm>
             </p:contentPart>
           </mc:Choice>
-          <mc:Fallback>
+          <mc:Fallback xmlns="">
             <p:pic>
               <p:nvPicPr>
                 <p:cNvPr id="76" name="Encre 75">
@@ -9926,8 +9927,8 @@
             </p:pic>
           </mc:Fallback>
         </mc:AlternateContent>
-        <mc:AlternateContent xmlns:mc="http://schemas.openxmlformats.org/markup-compatibility/2006">
-          <mc:Choice xmlns:p14="http://schemas.microsoft.com/office/powerpoint/2010/main" Requires="p14">
+        <mc:AlternateContent xmlns:mc="http://schemas.openxmlformats.org/markup-compatibility/2006" xmlns:p14="http://schemas.microsoft.com/office/powerpoint/2010/main">
+          <mc:Choice Requires="p14">
             <p:contentPart p14:bwMode="auto" r:id="rId94">
               <p14:nvContentPartPr>
                 <p14:cNvPr id="77" name="Encre 76">
@@ -9946,7 +9947,7 @@
               </p14:xfrm>
             </p:contentPart>
           </mc:Choice>
-          <mc:Fallback>
+          <mc:Fallback xmlns="">
             <p:pic>
               <p:nvPicPr>
                 <p:cNvPr id="77" name="Encre 76">
@@ -9977,8 +9978,8 @@
             </p:pic>
           </mc:Fallback>
         </mc:AlternateContent>
-        <mc:AlternateContent xmlns:mc="http://schemas.openxmlformats.org/markup-compatibility/2006">
-          <mc:Choice xmlns:p14="http://schemas.microsoft.com/office/powerpoint/2010/main" Requires="p14">
+        <mc:AlternateContent xmlns:mc="http://schemas.openxmlformats.org/markup-compatibility/2006" xmlns:p14="http://schemas.microsoft.com/office/powerpoint/2010/main">
+          <mc:Choice Requires="p14">
             <p:contentPart p14:bwMode="auto" r:id="rId96">
               <p14:nvContentPartPr>
                 <p14:cNvPr id="78" name="Encre 77">
@@ -9997,7 +9998,7 @@
               </p14:xfrm>
             </p:contentPart>
           </mc:Choice>
-          <mc:Fallback>
+          <mc:Fallback xmlns="">
             <p:pic>
               <p:nvPicPr>
                 <p:cNvPr id="78" name="Encre 77">
@@ -10028,8 +10029,8 @@
             </p:pic>
           </mc:Fallback>
         </mc:AlternateContent>
-        <mc:AlternateContent xmlns:mc="http://schemas.openxmlformats.org/markup-compatibility/2006">
-          <mc:Choice xmlns:p14="http://schemas.microsoft.com/office/powerpoint/2010/main" Requires="p14">
+        <mc:AlternateContent xmlns:mc="http://schemas.openxmlformats.org/markup-compatibility/2006" xmlns:p14="http://schemas.microsoft.com/office/powerpoint/2010/main">
+          <mc:Choice Requires="p14">
             <p:contentPart p14:bwMode="auto" r:id="rId98">
               <p14:nvContentPartPr>
                 <p14:cNvPr id="85" name="Encre 84">
@@ -10048,7 +10049,7 @@
               </p14:xfrm>
             </p:contentPart>
           </mc:Choice>
-          <mc:Fallback>
+          <mc:Fallback xmlns="">
             <p:pic>
               <p:nvPicPr>
                 <p:cNvPr id="85" name="Encre 84">
@@ -10079,8 +10080,8 @@
             </p:pic>
           </mc:Fallback>
         </mc:AlternateContent>
-        <mc:AlternateContent xmlns:mc="http://schemas.openxmlformats.org/markup-compatibility/2006">
-          <mc:Choice xmlns:p14="http://schemas.microsoft.com/office/powerpoint/2010/main" Requires="p14">
+        <mc:AlternateContent xmlns:mc="http://schemas.openxmlformats.org/markup-compatibility/2006" xmlns:p14="http://schemas.microsoft.com/office/powerpoint/2010/main">
+          <mc:Choice Requires="p14">
             <p:contentPart p14:bwMode="auto" r:id="rId100">
               <p14:nvContentPartPr>
                 <p14:cNvPr id="86" name="Encre 85">
@@ -10099,7 +10100,7 @@
               </p14:xfrm>
             </p:contentPart>
           </mc:Choice>
-          <mc:Fallback>
+          <mc:Fallback xmlns="">
             <p:pic>
               <p:nvPicPr>
                 <p:cNvPr id="86" name="Encre 85">
@@ -10130,8 +10131,8 @@
             </p:pic>
           </mc:Fallback>
         </mc:AlternateContent>
-        <mc:AlternateContent xmlns:mc="http://schemas.openxmlformats.org/markup-compatibility/2006">
-          <mc:Choice xmlns:p14="http://schemas.microsoft.com/office/powerpoint/2010/main" Requires="p14">
+        <mc:AlternateContent xmlns:mc="http://schemas.openxmlformats.org/markup-compatibility/2006" xmlns:p14="http://schemas.microsoft.com/office/powerpoint/2010/main">
+          <mc:Choice Requires="p14">
             <p:contentPart p14:bwMode="auto" r:id="rId102">
               <p14:nvContentPartPr>
                 <p14:cNvPr id="87" name="Encre 86">
@@ -10150,7 +10151,7 @@
               </p14:xfrm>
             </p:contentPart>
           </mc:Choice>
-          <mc:Fallback>
+          <mc:Fallback xmlns="">
             <p:pic>
               <p:nvPicPr>
                 <p:cNvPr id="87" name="Encre 86">
@@ -10181,8 +10182,8 @@
             </p:pic>
           </mc:Fallback>
         </mc:AlternateContent>
-        <mc:AlternateContent xmlns:mc="http://schemas.openxmlformats.org/markup-compatibility/2006">
-          <mc:Choice xmlns:p14="http://schemas.microsoft.com/office/powerpoint/2010/main" Requires="p14">
+        <mc:AlternateContent xmlns:mc="http://schemas.openxmlformats.org/markup-compatibility/2006" xmlns:p14="http://schemas.microsoft.com/office/powerpoint/2010/main">
+          <mc:Choice Requires="p14">
             <p:contentPart p14:bwMode="auto" r:id="rId104">
               <p14:nvContentPartPr>
                 <p14:cNvPr id="88" name="Encre 87">
@@ -10201,7 +10202,7 @@
               </p14:xfrm>
             </p:contentPart>
           </mc:Choice>
-          <mc:Fallback>
+          <mc:Fallback xmlns="">
             <p:pic>
               <p:nvPicPr>
                 <p:cNvPr id="88" name="Encre 87">
@@ -10232,8 +10233,8 @@
             </p:pic>
           </mc:Fallback>
         </mc:AlternateContent>
-        <mc:AlternateContent xmlns:mc="http://schemas.openxmlformats.org/markup-compatibility/2006">
-          <mc:Choice xmlns:p14="http://schemas.microsoft.com/office/powerpoint/2010/main" Requires="p14">
+        <mc:AlternateContent xmlns:mc="http://schemas.openxmlformats.org/markup-compatibility/2006" xmlns:p14="http://schemas.microsoft.com/office/powerpoint/2010/main">
+          <mc:Choice Requires="p14">
             <p:contentPart p14:bwMode="auto" r:id="rId105">
               <p14:nvContentPartPr>
                 <p14:cNvPr id="55" name="Encre 54">
@@ -10252,7 +10253,7 @@
               </p14:xfrm>
             </p:contentPart>
           </mc:Choice>
-          <mc:Fallback>
+          <mc:Fallback xmlns="">
             <p:pic>
               <p:nvPicPr>
                 <p:cNvPr id="55" name="Encre 54">
@@ -10283,8 +10284,8 @@
             </p:pic>
           </mc:Fallback>
         </mc:AlternateContent>
-        <mc:AlternateContent xmlns:mc="http://schemas.openxmlformats.org/markup-compatibility/2006">
-          <mc:Choice xmlns:p14="http://schemas.microsoft.com/office/powerpoint/2010/main" Requires="p14">
+        <mc:AlternateContent xmlns:mc="http://schemas.openxmlformats.org/markup-compatibility/2006" xmlns:p14="http://schemas.microsoft.com/office/powerpoint/2010/main">
+          <mc:Choice Requires="p14">
             <p:contentPart p14:bwMode="auto" r:id="rId106">
               <p14:nvContentPartPr>
                 <p14:cNvPr id="56" name="Encre 55">
@@ -10303,7 +10304,7 @@
               </p14:xfrm>
             </p:contentPart>
           </mc:Choice>
-          <mc:Fallback>
+          <mc:Fallback xmlns="">
             <p:pic>
               <p:nvPicPr>
                 <p:cNvPr id="56" name="Encre 55">
@@ -10334,8 +10335,8 @@
             </p:pic>
           </mc:Fallback>
         </mc:AlternateContent>
-        <mc:AlternateContent xmlns:mc="http://schemas.openxmlformats.org/markup-compatibility/2006">
-          <mc:Choice xmlns:p14="http://schemas.microsoft.com/office/powerpoint/2010/main" Requires="p14">
+        <mc:AlternateContent xmlns:mc="http://schemas.openxmlformats.org/markup-compatibility/2006" xmlns:p14="http://schemas.microsoft.com/office/powerpoint/2010/main">
+          <mc:Choice Requires="p14">
             <p:contentPart p14:bwMode="auto" r:id="rId108">
               <p14:nvContentPartPr>
                 <p14:cNvPr id="89" name="Encre 88">
@@ -10354,7 +10355,7 @@
               </p14:xfrm>
             </p:contentPart>
           </mc:Choice>
-          <mc:Fallback>
+          <mc:Fallback xmlns="">
             <p:pic>
               <p:nvPicPr>
                 <p:cNvPr id="89" name="Encre 88">
@@ -10385,8 +10386,8 @@
             </p:pic>
           </mc:Fallback>
         </mc:AlternateContent>
-        <mc:AlternateContent xmlns:mc="http://schemas.openxmlformats.org/markup-compatibility/2006">
-          <mc:Choice xmlns:p14="http://schemas.microsoft.com/office/powerpoint/2010/main" Requires="p14">
+        <mc:AlternateContent xmlns:mc="http://schemas.openxmlformats.org/markup-compatibility/2006" xmlns:p14="http://schemas.microsoft.com/office/powerpoint/2010/main">
+          <mc:Choice Requires="p14">
             <p:contentPart p14:bwMode="auto" r:id="rId110">
               <p14:nvContentPartPr>
                 <p14:cNvPr id="90" name="Encre 89">
@@ -10405,7 +10406,7 @@
               </p14:xfrm>
             </p:contentPart>
           </mc:Choice>
-          <mc:Fallback>
+          <mc:Fallback xmlns="">
             <p:pic>
               <p:nvPicPr>
                 <p:cNvPr id="90" name="Encre 89">
@@ -10436,8 +10437,8 @@
             </p:pic>
           </mc:Fallback>
         </mc:AlternateContent>
-        <mc:AlternateContent xmlns:mc="http://schemas.openxmlformats.org/markup-compatibility/2006">
-          <mc:Choice xmlns:p14="http://schemas.microsoft.com/office/powerpoint/2010/main" Requires="p14">
+        <mc:AlternateContent xmlns:mc="http://schemas.openxmlformats.org/markup-compatibility/2006" xmlns:p14="http://schemas.microsoft.com/office/powerpoint/2010/main">
+          <mc:Choice Requires="p14">
             <p:contentPart p14:bwMode="auto" r:id="rId112">
               <p14:nvContentPartPr>
                 <p14:cNvPr id="91" name="Encre 90">
@@ -10456,7 +10457,7 @@
               </p14:xfrm>
             </p:contentPart>
           </mc:Choice>
-          <mc:Fallback>
+          <mc:Fallback xmlns="">
             <p:pic>
               <p:nvPicPr>
                 <p:cNvPr id="91" name="Encre 90">
@@ -10487,8 +10488,8 @@
             </p:pic>
           </mc:Fallback>
         </mc:AlternateContent>
-        <mc:AlternateContent xmlns:mc="http://schemas.openxmlformats.org/markup-compatibility/2006">
-          <mc:Choice xmlns:p14="http://schemas.microsoft.com/office/powerpoint/2010/main" Requires="p14">
+        <mc:AlternateContent xmlns:mc="http://schemas.openxmlformats.org/markup-compatibility/2006" xmlns:p14="http://schemas.microsoft.com/office/powerpoint/2010/main">
+          <mc:Choice Requires="p14">
             <p:contentPart p14:bwMode="auto" r:id="rId114">
               <p14:nvContentPartPr>
                 <p14:cNvPr id="92" name="Encre 91">
@@ -10507,7 +10508,7 @@
               </p14:xfrm>
             </p:contentPart>
           </mc:Choice>
-          <mc:Fallback>
+          <mc:Fallback xmlns="">
             <p:pic>
               <p:nvPicPr>
                 <p:cNvPr id="92" name="Encre 91">
@@ -10538,8 +10539,8 @@
             </p:pic>
           </mc:Fallback>
         </mc:AlternateContent>
-        <mc:AlternateContent xmlns:mc="http://schemas.openxmlformats.org/markup-compatibility/2006">
-          <mc:Choice xmlns:p14="http://schemas.microsoft.com/office/powerpoint/2010/main" Requires="p14">
+        <mc:AlternateContent xmlns:mc="http://schemas.openxmlformats.org/markup-compatibility/2006" xmlns:p14="http://schemas.microsoft.com/office/powerpoint/2010/main">
+          <mc:Choice Requires="p14">
             <p:contentPart p14:bwMode="auto" r:id="rId116">
               <p14:nvContentPartPr>
                 <p14:cNvPr id="93" name="Encre 92">
@@ -10558,7 +10559,7 @@
               </p14:xfrm>
             </p:contentPart>
           </mc:Choice>
-          <mc:Fallback>
+          <mc:Fallback xmlns="">
             <p:pic>
               <p:nvPicPr>
                 <p:cNvPr id="93" name="Encre 92">
@@ -10589,8 +10590,8 @@
             </p:pic>
           </mc:Fallback>
         </mc:AlternateContent>
-        <mc:AlternateContent xmlns:mc="http://schemas.openxmlformats.org/markup-compatibility/2006">
-          <mc:Choice xmlns:p14="http://schemas.microsoft.com/office/powerpoint/2010/main" Requires="p14">
+        <mc:AlternateContent xmlns:mc="http://schemas.openxmlformats.org/markup-compatibility/2006" xmlns:p14="http://schemas.microsoft.com/office/powerpoint/2010/main">
+          <mc:Choice Requires="p14">
             <p:contentPart p14:bwMode="auto" r:id="rId117">
               <p14:nvContentPartPr>
                 <p14:cNvPr id="48" name="Encre 47">
@@ -10609,7 +10610,7 @@
               </p14:xfrm>
             </p:contentPart>
           </mc:Choice>
-          <mc:Fallback>
+          <mc:Fallback xmlns="">
             <p:pic>
               <p:nvPicPr>
                 <p:cNvPr id="48" name="Encre 47">
@@ -10640,8 +10641,8 @@
             </p:pic>
           </mc:Fallback>
         </mc:AlternateContent>
-        <mc:AlternateContent xmlns:mc="http://schemas.openxmlformats.org/markup-compatibility/2006">
-          <mc:Choice xmlns:p14="http://schemas.microsoft.com/office/powerpoint/2010/main" Requires="p14">
+        <mc:AlternateContent xmlns:mc="http://schemas.openxmlformats.org/markup-compatibility/2006" xmlns:p14="http://schemas.microsoft.com/office/powerpoint/2010/main">
+          <mc:Choice Requires="p14">
             <p:contentPart p14:bwMode="auto" r:id="rId119">
               <p14:nvContentPartPr>
                 <p14:cNvPr id="49" name="Encre 48">
@@ -10660,7 +10661,7 @@
               </p14:xfrm>
             </p:contentPart>
           </mc:Choice>
-          <mc:Fallback>
+          <mc:Fallback xmlns="">
             <p:pic>
               <p:nvPicPr>
                 <p:cNvPr id="49" name="Encre 48">
@@ -10691,8 +10692,8 @@
             </p:pic>
           </mc:Fallback>
         </mc:AlternateContent>
-        <mc:AlternateContent xmlns:mc="http://schemas.openxmlformats.org/markup-compatibility/2006">
-          <mc:Choice xmlns:p14="http://schemas.microsoft.com/office/powerpoint/2010/main" Requires="p14">
+        <mc:AlternateContent xmlns:mc="http://schemas.openxmlformats.org/markup-compatibility/2006" xmlns:p14="http://schemas.microsoft.com/office/powerpoint/2010/main">
+          <mc:Choice Requires="p14">
             <p:contentPart p14:bwMode="auto" r:id="rId121">
               <p14:nvContentPartPr>
                 <p14:cNvPr id="50" name="Encre 49">
@@ -10711,7 +10712,7 @@
               </p14:xfrm>
             </p:contentPart>
           </mc:Choice>
-          <mc:Fallback>
+          <mc:Fallback xmlns="">
             <p:pic>
               <p:nvPicPr>
                 <p:cNvPr id="50" name="Encre 49">
@@ -10742,8 +10743,8 @@
             </p:pic>
           </mc:Fallback>
         </mc:AlternateContent>
-        <mc:AlternateContent xmlns:mc="http://schemas.openxmlformats.org/markup-compatibility/2006">
-          <mc:Choice xmlns:p14="http://schemas.microsoft.com/office/powerpoint/2010/main" Requires="p14">
+        <mc:AlternateContent xmlns:mc="http://schemas.openxmlformats.org/markup-compatibility/2006" xmlns:p14="http://schemas.microsoft.com/office/powerpoint/2010/main">
+          <mc:Choice Requires="p14">
             <p:contentPart p14:bwMode="auto" r:id="rId123">
               <p14:nvContentPartPr>
                 <p14:cNvPr id="51" name="Encre 50">
@@ -10762,7 +10763,7 @@
               </p14:xfrm>
             </p:contentPart>
           </mc:Choice>
-          <mc:Fallback>
+          <mc:Fallback xmlns="">
             <p:pic>
               <p:nvPicPr>
                 <p:cNvPr id="51" name="Encre 50">
@@ -10793,8 +10794,8 @@
             </p:pic>
           </mc:Fallback>
         </mc:AlternateContent>
-        <mc:AlternateContent xmlns:mc="http://schemas.openxmlformats.org/markup-compatibility/2006">
-          <mc:Choice xmlns:p14="http://schemas.microsoft.com/office/powerpoint/2010/main" Requires="p14">
+        <mc:AlternateContent xmlns:mc="http://schemas.openxmlformats.org/markup-compatibility/2006" xmlns:p14="http://schemas.microsoft.com/office/powerpoint/2010/main">
+          <mc:Choice Requires="p14">
             <p:contentPart p14:bwMode="auto" r:id="rId125">
               <p14:nvContentPartPr>
                 <p14:cNvPr id="52" name="Encre 51">
@@ -10813,7 +10814,7 @@
               </p14:xfrm>
             </p:contentPart>
           </mc:Choice>
-          <mc:Fallback>
+          <mc:Fallback xmlns="">
             <p:pic>
               <p:nvPicPr>
                 <p:cNvPr id="52" name="Encre 51">
@@ -10844,8 +10845,8 @@
             </p:pic>
           </mc:Fallback>
         </mc:AlternateContent>
-        <mc:AlternateContent xmlns:mc="http://schemas.openxmlformats.org/markup-compatibility/2006">
-          <mc:Choice xmlns:p14="http://schemas.microsoft.com/office/powerpoint/2010/main" Requires="p14">
+        <mc:AlternateContent xmlns:mc="http://schemas.openxmlformats.org/markup-compatibility/2006" xmlns:p14="http://schemas.microsoft.com/office/powerpoint/2010/main">
+          <mc:Choice Requires="p14">
             <p:contentPart p14:bwMode="auto" r:id="rId127">
               <p14:nvContentPartPr>
                 <p14:cNvPr id="53" name="Encre 52">
@@ -10864,7 +10865,7 @@
               </p14:xfrm>
             </p:contentPart>
           </mc:Choice>
-          <mc:Fallback>
+          <mc:Fallback xmlns="">
             <p:pic>
               <p:nvPicPr>
                 <p:cNvPr id="53" name="Encre 52">
@@ -10895,8 +10896,8 @@
             </p:pic>
           </mc:Fallback>
         </mc:AlternateContent>
-        <mc:AlternateContent xmlns:mc="http://schemas.openxmlformats.org/markup-compatibility/2006">
-          <mc:Choice xmlns:p14="http://schemas.microsoft.com/office/powerpoint/2010/main" Requires="p14">
+        <mc:AlternateContent xmlns:mc="http://schemas.openxmlformats.org/markup-compatibility/2006" xmlns:p14="http://schemas.microsoft.com/office/powerpoint/2010/main">
+          <mc:Choice Requires="p14">
             <p:contentPart p14:bwMode="auto" r:id="rId128">
               <p14:nvContentPartPr>
                 <p14:cNvPr id="54" name="Encre 53">
@@ -10915,7 +10916,7 @@
               </p14:xfrm>
             </p:contentPart>
           </mc:Choice>
-          <mc:Fallback>
+          <mc:Fallback xmlns="">
             <p:pic>
               <p:nvPicPr>
                 <p:cNvPr id="54" name="Encre 53">
@@ -10946,8 +10947,8 @@
             </p:pic>
           </mc:Fallback>
         </mc:AlternateContent>
-        <mc:AlternateContent xmlns:mc="http://schemas.openxmlformats.org/markup-compatibility/2006">
-          <mc:Choice xmlns:p14="http://schemas.microsoft.com/office/powerpoint/2010/main" Requires="p14">
+        <mc:AlternateContent xmlns:mc="http://schemas.openxmlformats.org/markup-compatibility/2006" xmlns:p14="http://schemas.microsoft.com/office/powerpoint/2010/main">
+          <mc:Choice Requires="p14">
             <p:contentPart p14:bwMode="auto" r:id="rId130">
               <p14:nvContentPartPr>
                 <p14:cNvPr id="57" name="Encre 56">
@@ -10966,7 +10967,7 @@
               </p14:xfrm>
             </p:contentPart>
           </mc:Choice>
-          <mc:Fallback>
+          <mc:Fallback xmlns="">
             <p:pic>
               <p:nvPicPr>
                 <p:cNvPr id="57" name="Encre 56">
@@ -10997,8 +10998,8 @@
             </p:pic>
           </mc:Fallback>
         </mc:AlternateContent>
-        <mc:AlternateContent xmlns:mc="http://schemas.openxmlformats.org/markup-compatibility/2006">
-          <mc:Choice xmlns:p14="http://schemas.microsoft.com/office/powerpoint/2010/main" Requires="p14">
+        <mc:AlternateContent xmlns:mc="http://schemas.openxmlformats.org/markup-compatibility/2006" xmlns:p14="http://schemas.microsoft.com/office/powerpoint/2010/main">
+          <mc:Choice Requires="p14">
             <p:contentPart p14:bwMode="auto" r:id="rId132">
               <p14:nvContentPartPr>
                 <p14:cNvPr id="58" name="Encre 57">
@@ -11017,7 +11018,7 @@
               </p14:xfrm>
             </p:contentPart>
           </mc:Choice>
-          <mc:Fallback>
+          <mc:Fallback xmlns="">
             <p:pic>
               <p:nvPicPr>
                 <p:cNvPr id="58" name="Encre 57">
@@ -11048,8 +11049,8 @@
             </p:pic>
           </mc:Fallback>
         </mc:AlternateContent>
-        <mc:AlternateContent xmlns:mc="http://schemas.openxmlformats.org/markup-compatibility/2006">
-          <mc:Choice xmlns:p14="http://schemas.microsoft.com/office/powerpoint/2010/main" Requires="p14">
+        <mc:AlternateContent xmlns:mc="http://schemas.openxmlformats.org/markup-compatibility/2006" xmlns:p14="http://schemas.microsoft.com/office/powerpoint/2010/main">
+          <mc:Choice Requires="p14">
             <p:contentPart p14:bwMode="auto" r:id="rId134">
               <p14:nvContentPartPr>
                 <p14:cNvPr id="59" name="Encre 58">
@@ -11068,7 +11069,7 @@
               </p14:xfrm>
             </p:contentPart>
           </mc:Choice>
-          <mc:Fallback>
+          <mc:Fallback xmlns="">
             <p:pic>
               <p:nvPicPr>
                 <p:cNvPr id="59" name="Encre 58">
@@ -11099,8 +11100,8 @@
             </p:pic>
           </mc:Fallback>
         </mc:AlternateContent>
-        <mc:AlternateContent xmlns:mc="http://schemas.openxmlformats.org/markup-compatibility/2006">
-          <mc:Choice xmlns:p14="http://schemas.microsoft.com/office/powerpoint/2010/main" Requires="p14">
+        <mc:AlternateContent xmlns:mc="http://schemas.openxmlformats.org/markup-compatibility/2006" xmlns:p14="http://schemas.microsoft.com/office/powerpoint/2010/main">
+          <mc:Choice Requires="p14">
             <p:contentPart p14:bwMode="auto" r:id="rId136">
               <p14:nvContentPartPr>
                 <p14:cNvPr id="60" name="Encre 59">
@@ -11119,7 +11120,7 @@
               </p14:xfrm>
             </p:contentPart>
           </mc:Choice>
-          <mc:Fallback>
+          <mc:Fallback xmlns="">
             <p:pic>
               <p:nvPicPr>
                 <p:cNvPr id="60" name="Encre 59">
@@ -11150,8 +11151,8 @@
             </p:pic>
           </mc:Fallback>
         </mc:AlternateContent>
-        <mc:AlternateContent xmlns:mc="http://schemas.openxmlformats.org/markup-compatibility/2006">
-          <mc:Choice xmlns:p14="http://schemas.microsoft.com/office/powerpoint/2010/main" Requires="p14">
+        <mc:AlternateContent xmlns:mc="http://schemas.openxmlformats.org/markup-compatibility/2006" xmlns:p14="http://schemas.microsoft.com/office/powerpoint/2010/main">
+          <mc:Choice Requires="p14">
             <p:contentPart p14:bwMode="auto" r:id="rId138">
               <p14:nvContentPartPr>
                 <p14:cNvPr id="61" name="Encre 60">
@@ -11170,7 +11171,7 @@
               </p14:xfrm>
             </p:contentPart>
           </mc:Choice>
-          <mc:Fallback>
+          <mc:Fallback xmlns="">
             <p:pic>
               <p:nvPicPr>
                 <p:cNvPr id="61" name="Encre 60">
@@ -11201,8 +11202,8 @@
             </p:pic>
           </mc:Fallback>
         </mc:AlternateContent>
-        <mc:AlternateContent xmlns:mc="http://schemas.openxmlformats.org/markup-compatibility/2006">
-          <mc:Choice xmlns:p14="http://schemas.microsoft.com/office/powerpoint/2010/main" Requires="p14">
+        <mc:AlternateContent xmlns:mc="http://schemas.openxmlformats.org/markup-compatibility/2006" xmlns:p14="http://schemas.microsoft.com/office/powerpoint/2010/main">
+          <mc:Choice Requires="p14">
             <p:contentPart p14:bwMode="auto" r:id="rId139">
               <p14:nvContentPartPr>
                 <p14:cNvPr id="62" name="Encre 61">
@@ -11221,7 +11222,7 @@
               </p14:xfrm>
             </p:contentPart>
           </mc:Choice>
-          <mc:Fallback>
+          <mc:Fallback xmlns="">
             <p:pic>
               <p:nvPicPr>
                 <p:cNvPr id="62" name="Encre 61">
@@ -11252,8 +11253,8 @@
             </p:pic>
           </mc:Fallback>
         </mc:AlternateContent>
-        <mc:AlternateContent xmlns:mc="http://schemas.openxmlformats.org/markup-compatibility/2006">
-          <mc:Choice xmlns:p14="http://schemas.microsoft.com/office/powerpoint/2010/main" Requires="p14">
+        <mc:AlternateContent xmlns:mc="http://schemas.openxmlformats.org/markup-compatibility/2006" xmlns:p14="http://schemas.microsoft.com/office/powerpoint/2010/main">
+          <mc:Choice Requires="p14">
             <p:contentPart p14:bwMode="auto" r:id="rId140">
               <p14:nvContentPartPr>
                 <p14:cNvPr id="72" name="Encre 71">
@@ -11272,7 +11273,7 @@
               </p14:xfrm>
             </p:contentPart>
           </mc:Choice>
-          <mc:Fallback>
+          <mc:Fallback xmlns="">
             <p:pic>
               <p:nvPicPr>
                 <p:cNvPr id="72" name="Encre 71">
@@ -11303,8 +11304,8 @@
             </p:pic>
           </mc:Fallback>
         </mc:AlternateContent>
-        <mc:AlternateContent xmlns:mc="http://schemas.openxmlformats.org/markup-compatibility/2006">
-          <mc:Choice xmlns:p14="http://schemas.microsoft.com/office/powerpoint/2010/main" Requires="p14">
+        <mc:AlternateContent xmlns:mc="http://schemas.openxmlformats.org/markup-compatibility/2006" xmlns:p14="http://schemas.microsoft.com/office/powerpoint/2010/main">
+          <mc:Choice Requires="p14">
             <p:contentPart p14:bwMode="auto" r:id="rId142">
               <p14:nvContentPartPr>
                 <p14:cNvPr id="73" name="Encre 72">
@@ -11323,7 +11324,7 @@
               </p14:xfrm>
             </p:contentPart>
           </mc:Choice>
-          <mc:Fallback>
+          <mc:Fallback xmlns="">
             <p:pic>
               <p:nvPicPr>
                 <p:cNvPr id="73" name="Encre 72">
@@ -11354,8 +11355,8 @@
             </p:pic>
           </mc:Fallback>
         </mc:AlternateContent>
-        <mc:AlternateContent xmlns:mc="http://schemas.openxmlformats.org/markup-compatibility/2006">
-          <mc:Choice xmlns:p14="http://schemas.microsoft.com/office/powerpoint/2010/main" Requires="p14">
+        <mc:AlternateContent xmlns:mc="http://schemas.openxmlformats.org/markup-compatibility/2006" xmlns:p14="http://schemas.microsoft.com/office/powerpoint/2010/main">
+          <mc:Choice Requires="p14">
             <p:contentPart p14:bwMode="auto" r:id="rId144">
               <p14:nvContentPartPr>
                 <p14:cNvPr id="74" name="Encre 73">
@@ -11374,7 +11375,7 @@
               </p14:xfrm>
             </p:contentPart>
           </mc:Choice>
-          <mc:Fallback>
+          <mc:Fallback xmlns="">
             <p:pic>
               <p:nvPicPr>
                 <p:cNvPr id="74" name="Encre 73">
@@ -11405,8 +11406,8 @@
             </p:pic>
           </mc:Fallback>
         </mc:AlternateContent>
-        <mc:AlternateContent xmlns:mc="http://schemas.openxmlformats.org/markup-compatibility/2006">
-          <mc:Choice xmlns:p14="http://schemas.microsoft.com/office/powerpoint/2010/main" Requires="p14">
+        <mc:AlternateContent xmlns:mc="http://schemas.openxmlformats.org/markup-compatibility/2006" xmlns:p14="http://schemas.microsoft.com/office/powerpoint/2010/main">
+          <mc:Choice Requires="p14">
             <p:contentPart p14:bwMode="auto" r:id="rId146">
               <p14:nvContentPartPr>
                 <p14:cNvPr id="81" name="Encre 80">
@@ -11425,7 +11426,7 @@
               </p14:xfrm>
             </p:contentPart>
           </mc:Choice>
-          <mc:Fallback>
+          <mc:Fallback xmlns="">
             <p:pic>
               <p:nvPicPr>
                 <p:cNvPr id="81" name="Encre 80">
@@ -11456,8 +11457,8 @@
             </p:pic>
           </mc:Fallback>
         </mc:AlternateContent>
-        <mc:AlternateContent xmlns:mc="http://schemas.openxmlformats.org/markup-compatibility/2006">
-          <mc:Choice xmlns:p14="http://schemas.microsoft.com/office/powerpoint/2010/main" Requires="p14">
+        <mc:AlternateContent xmlns:mc="http://schemas.openxmlformats.org/markup-compatibility/2006" xmlns:p14="http://schemas.microsoft.com/office/powerpoint/2010/main">
+          <mc:Choice Requires="p14">
             <p:contentPart p14:bwMode="auto" r:id="rId148">
               <p14:nvContentPartPr>
                 <p14:cNvPr id="82" name="Encre 81">
@@ -11476,7 +11477,7 @@
               </p14:xfrm>
             </p:contentPart>
           </mc:Choice>
-          <mc:Fallback>
+          <mc:Fallback xmlns="">
             <p:pic>
               <p:nvPicPr>
                 <p:cNvPr id="82" name="Encre 81">
@@ -11507,8 +11508,8 @@
             </p:pic>
           </mc:Fallback>
         </mc:AlternateContent>
-        <mc:AlternateContent xmlns:mc="http://schemas.openxmlformats.org/markup-compatibility/2006">
-          <mc:Choice xmlns:p14="http://schemas.microsoft.com/office/powerpoint/2010/main" Requires="p14">
+        <mc:AlternateContent xmlns:mc="http://schemas.openxmlformats.org/markup-compatibility/2006" xmlns:p14="http://schemas.microsoft.com/office/powerpoint/2010/main">
+          <mc:Choice Requires="p14">
             <p:contentPart p14:bwMode="auto" r:id="rId150">
               <p14:nvContentPartPr>
                 <p14:cNvPr id="83" name="Encre 82">
@@ -11527,7 +11528,7 @@
               </p14:xfrm>
             </p:contentPart>
           </mc:Choice>
-          <mc:Fallback>
+          <mc:Fallback xmlns="">
             <p:pic>
               <p:nvPicPr>
                 <p:cNvPr id="83" name="Encre 82">
@@ -11558,8 +11559,8 @@
             </p:pic>
           </mc:Fallback>
         </mc:AlternateContent>
-        <mc:AlternateContent xmlns:mc="http://schemas.openxmlformats.org/markup-compatibility/2006">
-          <mc:Choice xmlns:p14="http://schemas.microsoft.com/office/powerpoint/2010/main" Requires="p14">
+        <mc:AlternateContent xmlns:mc="http://schemas.openxmlformats.org/markup-compatibility/2006" xmlns:p14="http://schemas.microsoft.com/office/powerpoint/2010/main">
+          <mc:Choice Requires="p14">
             <p:contentPart p14:bwMode="auto" r:id="rId152">
               <p14:nvContentPartPr>
                 <p14:cNvPr id="84" name="Encre 83">
@@ -11578,7 +11579,7 @@
               </p14:xfrm>
             </p:contentPart>
           </mc:Choice>
-          <mc:Fallback>
+          <mc:Fallback xmlns="">
             <p:pic>
               <p:nvPicPr>
                 <p:cNvPr id="84" name="Encre 83">
@@ -11609,8 +11610,8 @@
             </p:pic>
           </mc:Fallback>
         </mc:AlternateContent>
-        <mc:AlternateContent xmlns:mc="http://schemas.openxmlformats.org/markup-compatibility/2006">
-          <mc:Choice xmlns:p14="http://schemas.microsoft.com/office/powerpoint/2010/main" Requires="p14">
+        <mc:AlternateContent xmlns:mc="http://schemas.openxmlformats.org/markup-compatibility/2006" xmlns:p14="http://schemas.microsoft.com/office/powerpoint/2010/main">
+          <mc:Choice Requires="p14">
             <p:contentPart p14:bwMode="auto" r:id="rId154">
               <p14:nvContentPartPr>
                 <p14:cNvPr id="97" name="Encre 96">
@@ -11629,7 +11630,7 @@
               </p14:xfrm>
             </p:contentPart>
           </mc:Choice>
-          <mc:Fallback>
+          <mc:Fallback xmlns="">
             <p:pic>
               <p:nvPicPr>
                 <p:cNvPr id="97" name="Encre 96">
@@ -11660,8 +11661,8 @@
             </p:pic>
           </mc:Fallback>
         </mc:AlternateContent>
-        <mc:AlternateContent xmlns:mc="http://schemas.openxmlformats.org/markup-compatibility/2006">
-          <mc:Choice xmlns:p14="http://schemas.microsoft.com/office/powerpoint/2010/main" Requires="p14">
+        <mc:AlternateContent xmlns:mc="http://schemas.openxmlformats.org/markup-compatibility/2006" xmlns:p14="http://schemas.microsoft.com/office/powerpoint/2010/main">
+          <mc:Choice Requires="p14">
             <p:contentPart p14:bwMode="auto" r:id="rId156">
               <p14:nvContentPartPr>
                 <p14:cNvPr id="98" name="Encre 97">
@@ -11680,7 +11681,7 @@
               </p14:xfrm>
             </p:contentPart>
           </mc:Choice>
-          <mc:Fallback>
+          <mc:Fallback xmlns="">
             <p:pic>
               <p:nvPicPr>
                 <p:cNvPr id="98" name="Encre 97">
@@ -11711,8 +11712,8 @@
             </p:pic>
           </mc:Fallback>
         </mc:AlternateContent>
-        <mc:AlternateContent xmlns:mc="http://schemas.openxmlformats.org/markup-compatibility/2006">
-          <mc:Choice xmlns:p14="http://schemas.microsoft.com/office/powerpoint/2010/main" Requires="p14">
+        <mc:AlternateContent xmlns:mc="http://schemas.openxmlformats.org/markup-compatibility/2006" xmlns:p14="http://schemas.microsoft.com/office/powerpoint/2010/main">
+          <mc:Choice Requires="p14">
             <p:contentPart p14:bwMode="auto" r:id="rId158">
               <p14:nvContentPartPr>
                 <p14:cNvPr id="99" name="Encre 98">
@@ -11731,7 +11732,7 @@
               </p14:xfrm>
             </p:contentPart>
           </mc:Choice>
-          <mc:Fallback>
+          <mc:Fallback xmlns="">
             <p:pic>
               <p:nvPicPr>
                 <p:cNvPr id="99" name="Encre 98">
@@ -11762,8 +11763,8 @@
             </p:pic>
           </mc:Fallback>
         </mc:AlternateContent>
-        <mc:AlternateContent xmlns:mc="http://schemas.openxmlformats.org/markup-compatibility/2006">
-          <mc:Choice xmlns:p14="http://schemas.microsoft.com/office/powerpoint/2010/main" Requires="p14">
+        <mc:AlternateContent xmlns:mc="http://schemas.openxmlformats.org/markup-compatibility/2006" xmlns:p14="http://schemas.microsoft.com/office/powerpoint/2010/main">
+          <mc:Choice Requires="p14">
             <p:contentPart p14:bwMode="auto" r:id="rId160">
               <p14:nvContentPartPr>
                 <p14:cNvPr id="101" name="Encre 100">
@@ -11782,7 +11783,7 @@
               </p14:xfrm>
             </p:contentPart>
           </mc:Choice>
-          <mc:Fallback>
+          <mc:Fallback xmlns="">
             <p:pic>
               <p:nvPicPr>
                 <p:cNvPr id="101" name="Encre 100">
@@ -11813,8 +11814,8 @@
             </p:pic>
           </mc:Fallback>
         </mc:AlternateContent>
-        <mc:AlternateContent xmlns:mc="http://schemas.openxmlformats.org/markup-compatibility/2006">
-          <mc:Choice xmlns:p14="http://schemas.microsoft.com/office/powerpoint/2010/main" Requires="p14">
+        <mc:AlternateContent xmlns:mc="http://schemas.openxmlformats.org/markup-compatibility/2006" xmlns:p14="http://schemas.microsoft.com/office/powerpoint/2010/main">
+          <mc:Choice Requires="p14">
             <p:contentPart p14:bwMode="auto" r:id="rId162">
               <p14:nvContentPartPr>
                 <p14:cNvPr id="102" name="Encre 101">
@@ -11833,7 +11834,7 @@
               </p14:xfrm>
             </p:contentPart>
           </mc:Choice>
-          <mc:Fallback>
+          <mc:Fallback xmlns="">
             <p:pic>
               <p:nvPicPr>
                 <p:cNvPr id="102" name="Encre 101">
@@ -11864,8 +11865,8 @@
             </p:pic>
           </mc:Fallback>
         </mc:AlternateContent>
-        <mc:AlternateContent xmlns:mc="http://schemas.openxmlformats.org/markup-compatibility/2006">
-          <mc:Choice xmlns:p14="http://schemas.microsoft.com/office/powerpoint/2010/main" Requires="p14">
+        <mc:AlternateContent xmlns:mc="http://schemas.openxmlformats.org/markup-compatibility/2006" xmlns:p14="http://schemas.microsoft.com/office/powerpoint/2010/main">
+          <mc:Choice Requires="p14">
             <p:contentPart p14:bwMode="auto" r:id="rId164">
               <p14:nvContentPartPr>
                 <p14:cNvPr id="104" name="Encre 103">
@@ -11884,7 +11885,7 @@
               </p14:xfrm>
             </p:contentPart>
           </mc:Choice>
-          <mc:Fallback>
+          <mc:Fallback xmlns="">
             <p:pic>
               <p:nvPicPr>
                 <p:cNvPr id="104" name="Encre 103">
@@ -11915,8 +11916,8 @@
             </p:pic>
           </mc:Fallback>
         </mc:AlternateContent>
-        <mc:AlternateContent xmlns:mc="http://schemas.openxmlformats.org/markup-compatibility/2006">
-          <mc:Choice xmlns:p14="http://schemas.microsoft.com/office/powerpoint/2010/main" Requires="p14">
+        <mc:AlternateContent xmlns:mc="http://schemas.openxmlformats.org/markup-compatibility/2006" xmlns:p14="http://schemas.microsoft.com/office/powerpoint/2010/main">
+          <mc:Choice Requires="p14">
             <p:contentPart p14:bwMode="auto" r:id="rId166">
               <p14:nvContentPartPr>
                 <p14:cNvPr id="105" name="Encre 104">
@@ -11935,7 +11936,7 @@
               </p14:xfrm>
             </p:contentPart>
           </mc:Choice>
-          <mc:Fallback>
+          <mc:Fallback xmlns="">
             <p:pic>
               <p:nvPicPr>
                 <p:cNvPr id="105" name="Encre 104">
@@ -11967,8 +11968,8 @@
           </mc:Fallback>
         </mc:AlternateContent>
       </p:grpSp>
-      <mc:AlternateContent xmlns:mc="http://schemas.openxmlformats.org/markup-compatibility/2006">
-        <mc:Choice xmlns:p14="http://schemas.microsoft.com/office/powerpoint/2010/main" Requires="p14">
+      <mc:AlternateContent xmlns:mc="http://schemas.openxmlformats.org/markup-compatibility/2006" xmlns:p14="http://schemas.microsoft.com/office/powerpoint/2010/main">
+        <mc:Choice Requires="p14">
           <p:contentPart p14:bwMode="auto" r:id="rId168">
             <p14:nvContentPartPr>
               <p14:cNvPr id="107" name="Encre 106">
@@ -11987,7 +11988,7 @@
             </p14:xfrm>
           </p:contentPart>
         </mc:Choice>
-        <mc:Fallback>
+        <mc:Fallback xmlns="">
           <p:pic>
             <p:nvPicPr>
               <p:cNvPr id="107" name="Encre 106">
@@ -12038,8 +12039,8 @@
             <a:chExt cx="752400" cy="172440"/>
           </a:xfrm>
         </p:grpSpPr>
-        <mc:AlternateContent xmlns:mc="http://schemas.openxmlformats.org/markup-compatibility/2006">
-          <mc:Choice xmlns:p14="http://schemas.microsoft.com/office/powerpoint/2010/main" Requires="p14">
+        <mc:AlternateContent xmlns:mc="http://schemas.openxmlformats.org/markup-compatibility/2006" xmlns:p14="http://schemas.microsoft.com/office/powerpoint/2010/main">
+          <mc:Choice Requires="p14">
             <p:contentPart p14:bwMode="auto" r:id="rId170">
               <p14:nvContentPartPr>
                 <p14:cNvPr id="108" name="Encre 107">
@@ -12058,7 +12059,7 @@
               </p14:xfrm>
             </p:contentPart>
           </mc:Choice>
-          <mc:Fallback>
+          <mc:Fallback xmlns="">
             <p:pic>
               <p:nvPicPr>
                 <p:cNvPr id="108" name="Encre 107">
@@ -12089,8 +12090,8 @@
             </p:pic>
           </mc:Fallback>
         </mc:AlternateContent>
-        <mc:AlternateContent xmlns:mc="http://schemas.openxmlformats.org/markup-compatibility/2006">
-          <mc:Choice xmlns:p14="http://schemas.microsoft.com/office/powerpoint/2010/main" Requires="p14">
+        <mc:AlternateContent xmlns:mc="http://schemas.openxmlformats.org/markup-compatibility/2006" xmlns:p14="http://schemas.microsoft.com/office/powerpoint/2010/main">
+          <mc:Choice Requires="p14">
             <p:contentPart p14:bwMode="auto" r:id="rId172">
               <p14:nvContentPartPr>
                 <p14:cNvPr id="109" name="Encre 108">
@@ -12109,7 +12110,7 @@
               </p14:xfrm>
             </p:contentPart>
           </mc:Choice>
-          <mc:Fallback>
+          <mc:Fallback xmlns="">
             <p:pic>
               <p:nvPicPr>
                 <p:cNvPr id="109" name="Encre 108">
@@ -12140,8 +12141,8 @@
             </p:pic>
           </mc:Fallback>
         </mc:AlternateContent>
-        <mc:AlternateContent xmlns:mc="http://schemas.openxmlformats.org/markup-compatibility/2006">
-          <mc:Choice xmlns:p14="http://schemas.microsoft.com/office/powerpoint/2010/main" Requires="p14">
+        <mc:AlternateContent xmlns:mc="http://schemas.openxmlformats.org/markup-compatibility/2006" xmlns:p14="http://schemas.microsoft.com/office/powerpoint/2010/main">
+          <mc:Choice Requires="p14">
             <p:contentPart p14:bwMode="auto" r:id="rId174">
               <p14:nvContentPartPr>
                 <p14:cNvPr id="110" name="Encre 109">
@@ -12160,7 +12161,7 @@
               </p14:xfrm>
             </p:contentPart>
           </mc:Choice>
-          <mc:Fallback>
+          <mc:Fallback xmlns="">
             <p:pic>
               <p:nvPicPr>
                 <p:cNvPr id="110" name="Encre 109">
@@ -12191,8 +12192,8 @@
             </p:pic>
           </mc:Fallback>
         </mc:AlternateContent>
-        <mc:AlternateContent xmlns:mc="http://schemas.openxmlformats.org/markup-compatibility/2006">
-          <mc:Choice xmlns:p14="http://schemas.microsoft.com/office/powerpoint/2010/main" Requires="p14">
+        <mc:AlternateContent xmlns:mc="http://schemas.openxmlformats.org/markup-compatibility/2006" xmlns:p14="http://schemas.microsoft.com/office/powerpoint/2010/main">
+          <mc:Choice Requires="p14">
             <p:contentPart p14:bwMode="auto" r:id="rId176">
               <p14:nvContentPartPr>
                 <p14:cNvPr id="111" name="Encre 110">
@@ -12211,7 +12212,7 @@
               </p14:xfrm>
             </p:contentPart>
           </mc:Choice>
-          <mc:Fallback>
+          <mc:Fallback xmlns="">
             <p:pic>
               <p:nvPicPr>
                 <p:cNvPr id="111" name="Encre 110">
@@ -12243,8 +12244,8 @@
           </mc:Fallback>
         </mc:AlternateContent>
       </p:grpSp>
-      <mc:AlternateContent xmlns:mc="http://schemas.openxmlformats.org/markup-compatibility/2006">
-        <mc:Choice xmlns:p14="http://schemas.microsoft.com/office/powerpoint/2010/main" Requires="p14">
+      <mc:AlternateContent xmlns:mc="http://schemas.openxmlformats.org/markup-compatibility/2006" xmlns:p14="http://schemas.microsoft.com/office/powerpoint/2010/main">
+        <mc:Choice Requires="p14">
           <p:contentPart p14:bwMode="auto" r:id="rId178">
             <p14:nvContentPartPr>
               <p14:cNvPr id="112" name="Encre 111">
@@ -12263,7 +12264,7 @@
             </p14:xfrm>
           </p:contentPart>
         </mc:Choice>
-        <mc:Fallback>
+        <mc:Fallback xmlns="">
           <p:pic>
             <p:nvPicPr>
               <p:cNvPr id="112" name="Encre 111">
@@ -12314,8 +12315,8 @@
             <a:chExt cx="1803600" cy="212040"/>
           </a:xfrm>
         </p:grpSpPr>
-        <mc:AlternateContent xmlns:mc="http://schemas.openxmlformats.org/markup-compatibility/2006">
-          <mc:Choice xmlns:p14="http://schemas.microsoft.com/office/powerpoint/2010/main" Requires="p14">
+        <mc:AlternateContent xmlns:mc="http://schemas.openxmlformats.org/markup-compatibility/2006" xmlns:p14="http://schemas.microsoft.com/office/powerpoint/2010/main">
+          <mc:Choice Requires="p14">
             <p:contentPart p14:bwMode="auto" r:id="rId180">
               <p14:nvContentPartPr>
                 <p14:cNvPr id="114" name="Encre 113">
@@ -12334,7 +12335,7 @@
               </p14:xfrm>
             </p:contentPart>
           </mc:Choice>
-          <mc:Fallback>
+          <mc:Fallback xmlns="">
             <p:pic>
               <p:nvPicPr>
                 <p:cNvPr id="114" name="Encre 113">
@@ -12365,8 +12366,8 @@
             </p:pic>
           </mc:Fallback>
         </mc:AlternateContent>
-        <mc:AlternateContent xmlns:mc="http://schemas.openxmlformats.org/markup-compatibility/2006">
-          <mc:Choice xmlns:p14="http://schemas.microsoft.com/office/powerpoint/2010/main" Requires="p14">
+        <mc:AlternateContent xmlns:mc="http://schemas.openxmlformats.org/markup-compatibility/2006" xmlns:p14="http://schemas.microsoft.com/office/powerpoint/2010/main">
+          <mc:Choice Requires="p14">
             <p:contentPart p14:bwMode="auto" r:id="rId182">
               <p14:nvContentPartPr>
                 <p14:cNvPr id="115" name="Encre 114">
@@ -12385,7 +12386,7 @@
               </p14:xfrm>
             </p:contentPart>
           </mc:Choice>
-          <mc:Fallback>
+          <mc:Fallback xmlns="">
             <p:pic>
               <p:nvPicPr>
                 <p:cNvPr id="115" name="Encre 114">
@@ -12416,8 +12417,8 @@
             </p:pic>
           </mc:Fallback>
         </mc:AlternateContent>
-        <mc:AlternateContent xmlns:mc="http://schemas.openxmlformats.org/markup-compatibility/2006">
-          <mc:Choice xmlns:p14="http://schemas.microsoft.com/office/powerpoint/2010/main" Requires="p14">
+        <mc:AlternateContent xmlns:mc="http://schemas.openxmlformats.org/markup-compatibility/2006" xmlns:p14="http://schemas.microsoft.com/office/powerpoint/2010/main">
+          <mc:Choice Requires="p14">
             <p:contentPart p14:bwMode="auto" r:id="rId184">
               <p14:nvContentPartPr>
                 <p14:cNvPr id="116" name="Encre 115">
@@ -12436,7 +12437,7 @@
               </p14:xfrm>
             </p:contentPart>
           </mc:Choice>
-          <mc:Fallback>
+          <mc:Fallback xmlns="">
             <p:pic>
               <p:nvPicPr>
                 <p:cNvPr id="116" name="Encre 115">
@@ -12467,8 +12468,8 @@
             </p:pic>
           </mc:Fallback>
         </mc:AlternateContent>
-        <mc:AlternateContent xmlns:mc="http://schemas.openxmlformats.org/markup-compatibility/2006">
-          <mc:Choice xmlns:p14="http://schemas.microsoft.com/office/powerpoint/2010/main" Requires="p14">
+        <mc:AlternateContent xmlns:mc="http://schemas.openxmlformats.org/markup-compatibility/2006" xmlns:p14="http://schemas.microsoft.com/office/powerpoint/2010/main">
+          <mc:Choice Requires="p14">
             <p:contentPart p14:bwMode="auto" r:id="rId186">
               <p14:nvContentPartPr>
                 <p14:cNvPr id="117" name="Encre 116">
@@ -12487,7 +12488,7 @@
               </p14:xfrm>
             </p:contentPart>
           </mc:Choice>
-          <mc:Fallback>
+          <mc:Fallback xmlns="">
             <p:pic>
               <p:nvPicPr>
                 <p:cNvPr id="117" name="Encre 116">
@@ -12518,8 +12519,8 @@
             </p:pic>
           </mc:Fallback>
         </mc:AlternateContent>
-        <mc:AlternateContent xmlns:mc="http://schemas.openxmlformats.org/markup-compatibility/2006">
-          <mc:Choice xmlns:p14="http://schemas.microsoft.com/office/powerpoint/2010/main" Requires="p14">
+        <mc:AlternateContent xmlns:mc="http://schemas.openxmlformats.org/markup-compatibility/2006" xmlns:p14="http://schemas.microsoft.com/office/powerpoint/2010/main">
+          <mc:Choice Requires="p14">
             <p:contentPart p14:bwMode="auto" r:id="rId188">
               <p14:nvContentPartPr>
                 <p14:cNvPr id="118" name="Encre 117">
@@ -12538,7 +12539,7 @@
               </p14:xfrm>
             </p:contentPart>
           </mc:Choice>
-          <mc:Fallback>
+          <mc:Fallback xmlns="">
             <p:pic>
               <p:nvPicPr>
                 <p:cNvPr id="118" name="Encre 117">
@@ -12569,8 +12570,8 @@
             </p:pic>
           </mc:Fallback>
         </mc:AlternateContent>
-        <mc:AlternateContent xmlns:mc="http://schemas.openxmlformats.org/markup-compatibility/2006">
-          <mc:Choice xmlns:p14="http://schemas.microsoft.com/office/powerpoint/2010/main" Requires="p14">
+        <mc:AlternateContent xmlns:mc="http://schemas.openxmlformats.org/markup-compatibility/2006" xmlns:p14="http://schemas.microsoft.com/office/powerpoint/2010/main">
+          <mc:Choice Requires="p14">
             <p:contentPart p14:bwMode="auto" r:id="rId190">
               <p14:nvContentPartPr>
                 <p14:cNvPr id="119" name="Encre 118">
@@ -12589,7 +12590,7 @@
               </p14:xfrm>
             </p:contentPart>
           </mc:Choice>
-          <mc:Fallback>
+          <mc:Fallback xmlns="">
             <p:pic>
               <p:nvPicPr>
                 <p:cNvPr id="119" name="Encre 118">
@@ -12620,8 +12621,8 @@
             </p:pic>
           </mc:Fallback>
         </mc:AlternateContent>
-        <mc:AlternateContent xmlns:mc="http://schemas.openxmlformats.org/markup-compatibility/2006">
-          <mc:Choice xmlns:p14="http://schemas.microsoft.com/office/powerpoint/2010/main" Requires="p14">
+        <mc:AlternateContent xmlns:mc="http://schemas.openxmlformats.org/markup-compatibility/2006" xmlns:p14="http://schemas.microsoft.com/office/powerpoint/2010/main">
+          <mc:Choice Requires="p14">
             <p:contentPart p14:bwMode="auto" r:id="rId192">
               <p14:nvContentPartPr>
                 <p14:cNvPr id="120" name="Encre 119">
@@ -12640,7 +12641,7 @@
               </p14:xfrm>
             </p:contentPart>
           </mc:Choice>
-          <mc:Fallback>
+          <mc:Fallback xmlns="">
             <p:pic>
               <p:nvPicPr>
                 <p:cNvPr id="120" name="Encre 119">
@@ -12671,8 +12672,8 @@
             </p:pic>
           </mc:Fallback>
         </mc:AlternateContent>
-        <mc:AlternateContent xmlns:mc="http://schemas.openxmlformats.org/markup-compatibility/2006">
-          <mc:Choice xmlns:p14="http://schemas.microsoft.com/office/powerpoint/2010/main" Requires="p14">
+        <mc:AlternateContent xmlns:mc="http://schemas.openxmlformats.org/markup-compatibility/2006" xmlns:p14="http://schemas.microsoft.com/office/powerpoint/2010/main">
+          <mc:Choice Requires="p14">
             <p:contentPart p14:bwMode="auto" r:id="rId194">
               <p14:nvContentPartPr>
                 <p14:cNvPr id="121" name="Encre 120">
@@ -12691,7 +12692,7 @@
               </p14:xfrm>
             </p:contentPart>
           </mc:Choice>
-          <mc:Fallback>
+          <mc:Fallback xmlns="">
             <p:pic>
               <p:nvPicPr>
                 <p:cNvPr id="121" name="Encre 120">
@@ -12722,8 +12723,8 @@
             </p:pic>
           </mc:Fallback>
         </mc:AlternateContent>
-        <mc:AlternateContent xmlns:mc="http://schemas.openxmlformats.org/markup-compatibility/2006">
-          <mc:Choice xmlns:p14="http://schemas.microsoft.com/office/powerpoint/2010/main" Requires="p14">
+        <mc:AlternateContent xmlns:mc="http://schemas.openxmlformats.org/markup-compatibility/2006" xmlns:p14="http://schemas.microsoft.com/office/powerpoint/2010/main">
+          <mc:Choice Requires="p14">
             <p:contentPart p14:bwMode="auto" r:id="rId196">
               <p14:nvContentPartPr>
                 <p14:cNvPr id="122" name="Encre 121">
@@ -12742,7 +12743,7 @@
               </p14:xfrm>
             </p:contentPart>
           </mc:Choice>
-          <mc:Fallback>
+          <mc:Fallback xmlns="">
             <p:pic>
               <p:nvPicPr>
                 <p:cNvPr id="122" name="Encre 121">
@@ -12794,8 +12795,8 @@
             <a:chExt cx="173160" cy="173520"/>
           </a:xfrm>
         </p:grpSpPr>
-        <mc:AlternateContent xmlns:mc="http://schemas.openxmlformats.org/markup-compatibility/2006">
-          <mc:Choice xmlns:p14="http://schemas.microsoft.com/office/powerpoint/2010/main" Requires="p14">
+        <mc:AlternateContent xmlns:mc="http://schemas.openxmlformats.org/markup-compatibility/2006" xmlns:p14="http://schemas.microsoft.com/office/powerpoint/2010/main">
+          <mc:Choice Requires="p14">
             <p:contentPart p14:bwMode="auto" r:id="rId198">
               <p14:nvContentPartPr>
                 <p14:cNvPr id="123" name="Encre 122">
@@ -12814,7 +12815,7 @@
               </p14:xfrm>
             </p:contentPart>
           </mc:Choice>
-          <mc:Fallback>
+          <mc:Fallback xmlns="">
             <p:pic>
               <p:nvPicPr>
                 <p:cNvPr id="123" name="Encre 122">
@@ -12845,8 +12846,8 @@
             </p:pic>
           </mc:Fallback>
         </mc:AlternateContent>
-        <mc:AlternateContent xmlns:mc="http://schemas.openxmlformats.org/markup-compatibility/2006">
-          <mc:Choice xmlns:p14="http://schemas.microsoft.com/office/powerpoint/2010/main" Requires="p14">
+        <mc:AlternateContent xmlns:mc="http://schemas.openxmlformats.org/markup-compatibility/2006" xmlns:p14="http://schemas.microsoft.com/office/powerpoint/2010/main">
+          <mc:Choice Requires="p14">
             <p:contentPart p14:bwMode="auto" r:id="rId200">
               <p14:nvContentPartPr>
                 <p14:cNvPr id="124" name="Encre 123">
@@ -12865,7 +12866,7 @@
               </p14:xfrm>
             </p:contentPart>
           </mc:Choice>
-          <mc:Fallback>
+          <mc:Fallback xmlns="">
             <p:pic>
               <p:nvPicPr>
                 <p:cNvPr id="124" name="Encre 123">
@@ -12917,8 +12918,8 @@
             <a:chExt cx="937080" cy="191160"/>
           </a:xfrm>
         </p:grpSpPr>
-        <mc:AlternateContent xmlns:mc="http://schemas.openxmlformats.org/markup-compatibility/2006">
-          <mc:Choice xmlns:p14="http://schemas.microsoft.com/office/powerpoint/2010/main" Requires="p14">
+        <mc:AlternateContent xmlns:mc="http://schemas.openxmlformats.org/markup-compatibility/2006" xmlns:p14="http://schemas.microsoft.com/office/powerpoint/2010/main">
+          <mc:Choice Requires="p14">
             <p:contentPart p14:bwMode="auto" r:id="rId202">
               <p14:nvContentPartPr>
                 <p14:cNvPr id="127" name="Encre 126">
@@ -12937,7 +12938,7 @@
               </p14:xfrm>
             </p:contentPart>
           </mc:Choice>
-          <mc:Fallback>
+          <mc:Fallback xmlns="">
             <p:pic>
               <p:nvPicPr>
                 <p:cNvPr id="127" name="Encre 126">
@@ -12968,8 +12969,8 @@
             </p:pic>
           </mc:Fallback>
         </mc:AlternateContent>
-        <mc:AlternateContent xmlns:mc="http://schemas.openxmlformats.org/markup-compatibility/2006">
-          <mc:Choice xmlns:p14="http://schemas.microsoft.com/office/powerpoint/2010/main" Requires="p14">
+        <mc:AlternateContent xmlns:mc="http://schemas.openxmlformats.org/markup-compatibility/2006" xmlns:p14="http://schemas.microsoft.com/office/powerpoint/2010/main">
+          <mc:Choice Requires="p14">
             <p:contentPart p14:bwMode="auto" r:id="rId204">
               <p14:nvContentPartPr>
                 <p14:cNvPr id="128" name="Encre 127">
@@ -12988,7 +12989,7 @@
               </p14:xfrm>
             </p:contentPart>
           </mc:Choice>
-          <mc:Fallback>
+          <mc:Fallback xmlns="">
             <p:pic>
               <p:nvPicPr>
                 <p:cNvPr id="128" name="Encre 127">
@@ -13019,8 +13020,8 @@
             </p:pic>
           </mc:Fallback>
         </mc:AlternateContent>
-        <mc:AlternateContent xmlns:mc="http://schemas.openxmlformats.org/markup-compatibility/2006">
-          <mc:Choice xmlns:p14="http://schemas.microsoft.com/office/powerpoint/2010/main" Requires="p14">
+        <mc:AlternateContent xmlns:mc="http://schemas.openxmlformats.org/markup-compatibility/2006" xmlns:p14="http://schemas.microsoft.com/office/powerpoint/2010/main">
+          <mc:Choice Requires="p14">
             <p:contentPart p14:bwMode="auto" r:id="rId206">
               <p14:nvContentPartPr>
                 <p14:cNvPr id="129" name="Encre 128">
@@ -13039,7 +13040,7 @@
               </p14:xfrm>
             </p:contentPart>
           </mc:Choice>
-          <mc:Fallback>
+          <mc:Fallback xmlns="">
             <p:pic>
               <p:nvPicPr>
                 <p:cNvPr id="129" name="Encre 128">
@@ -13070,8 +13071,8 @@
             </p:pic>
           </mc:Fallback>
         </mc:AlternateContent>
-        <mc:AlternateContent xmlns:mc="http://schemas.openxmlformats.org/markup-compatibility/2006">
-          <mc:Choice xmlns:p14="http://schemas.microsoft.com/office/powerpoint/2010/main" Requires="p14">
+        <mc:AlternateContent xmlns:mc="http://schemas.openxmlformats.org/markup-compatibility/2006" xmlns:p14="http://schemas.microsoft.com/office/powerpoint/2010/main">
+          <mc:Choice Requires="p14">
             <p:contentPart p14:bwMode="auto" r:id="rId208">
               <p14:nvContentPartPr>
                 <p14:cNvPr id="130" name="Encre 129">
@@ -13090,7 +13091,7 @@
               </p14:xfrm>
             </p:contentPart>
           </mc:Choice>
-          <mc:Fallback>
+          <mc:Fallback xmlns="">
             <p:pic>
               <p:nvPicPr>
                 <p:cNvPr id="130" name="Encre 129">
@@ -13122,8 +13123,8 @@
           </mc:Fallback>
         </mc:AlternateContent>
       </p:grpSp>
-      <mc:AlternateContent xmlns:mc="http://schemas.openxmlformats.org/markup-compatibility/2006">
-        <mc:Choice xmlns:p14="http://schemas.microsoft.com/office/powerpoint/2010/main" Requires="p14">
+      <mc:AlternateContent xmlns:mc="http://schemas.openxmlformats.org/markup-compatibility/2006" xmlns:p14="http://schemas.microsoft.com/office/powerpoint/2010/main">
+        <mc:Choice Requires="p14">
           <p:contentPart p14:bwMode="auto" r:id="rId210">
             <p14:nvContentPartPr>
               <p14:cNvPr id="131" name="Encre 130">
@@ -13142,7 +13143,7 @@
             </p14:xfrm>
           </p:contentPart>
         </mc:Choice>
-        <mc:Fallback>
+        <mc:Fallback xmlns="">
           <p:pic>
             <p:nvPicPr>
               <p:cNvPr id="131" name="Encre 130">
@@ -13173,8 +13174,8 @@
           </p:pic>
         </mc:Fallback>
       </mc:AlternateContent>
-      <mc:AlternateContent xmlns:mc="http://schemas.openxmlformats.org/markup-compatibility/2006">
-        <mc:Choice xmlns:p14="http://schemas.microsoft.com/office/powerpoint/2010/main" Requires="p14">
+      <mc:AlternateContent xmlns:mc="http://schemas.openxmlformats.org/markup-compatibility/2006" xmlns:p14="http://schemas.microsoft.com/office/powerpoint/2010/main">
+        <mc:Choice Requires="p14">
           <p:contentPart p14:bwMode="auto" r:id="rId212">
             <p14:nvContentPartPr>
               <p14:cNvPr id="133" name="Encre 132">
@@ -13193,7 +13194,7 @@
             </p14:xfrm>
           </p:contentPart>
         </mc:Choice>
-        <mc:Fallback>
+        <mc:Fallback xmlns="">
           <p:pic>
             <p:nvPicPr>
               <p:cNvPr id="133" name="Encre 132">
@@ -13224,8 +13225,8 @@
           </p:pic>
         </mc:Fallback>
       </mc:AlternateContent>
-      <mc:AlternateContent xmlns:mc="http://schemas.openxmlformats.org/markup-compatibility/2006">
-        <mc:Choice xmlns:p14="http://schemas.microsoft.com/office/powerpoint/2010/main" Requires="p14">
+      <mc:AlternateContent xmlns:mc="http://schemas.openxmlformats.org/markup-compatibility/2006" xmlns:p14="http://schemas.microsoft.com/office/powerpoint/2010/main">
+        <mc:Choice Requires="p14">
           <p:contentPart p14:bwMode="auto" r:id="rId214">
             <p14:nvContentPartPr>
               <p14:cNvPr id="134" name="Encre 133">
@@ -13244,7 +13245,7 @@
             </p14:xfrm>
           </p:contentPart>
         </mc:Choice>
-        <mc:Fallback>
+        <mc:Fallback xmlns="">
           <p:pic>
             <p:nvPicPr>
               <p:cNvPr id="134" name="Encre 133">
@@ -13326,8 +13327,8 @@
             <a:chExt cx="1442160" cy="532440"/>
           </a:xfrm>
         </p:grpSpPr>
-        <mc:AlternateContent xmlns:mc="http://schemas.openxmlformats.org/markup-compatibility/2006">
-          <mc:Choice xmlns:p14="http://schemas.microsoft.com/office/powerpoint/2010/main" Requires="p14">
+        <mc:AlternateContent xmlns:mc="http://schemas.openxmlformats.org/markup-compatibility/2006" xmlns:p14="http://schemas.microsoft.com/office/powerpoint/2010/main">
+          <mc:Choice Requires="p14">
             <p:contentPart p14:bwMode="auto" r:id="rId216">
               <p14:nvContentPartPr>
                 <p14:cNvPr id="136" name="Encre 135">
@@ -13346,7 +13347,7 @@
               </p14:xfrm>
             </p:contentPart>
           </mc:Choice>
-          <mc:Fallback>
+          <mc:Fallback xmlns="">
             <p:pic>
               <p:nvPicPr>
                 <p:cNvPr id="136" name="Encre 135">
@@ -13377,8 +13378,8 @@
             </p:pic>
           </mc:Fallback>
         </mc:AlternateContent>
-        <mc:AlternateContent xmlns:mc="http://schemas.openxmlformats.org/markup-compatibility/2006">
-          <mc:Choice xmlns:p14="http://schemas.microsoft.com/office/powerpoint/2010/main" Requires="p14">
+        <mc:AlternateContent xmlns:mc="http://schemas.openxmlformats.org/markup-compatibility/2006" xmlns:p14="http://schemas.microsoft.com/office/powerpoint/2010/main">
+          <mc:Choice Requires="p14">
             <p:contentPart p14:bwMode="auto" r:id="rId218">
               <p14:nvContentPartPr>
                 <p14:cNvPr id="137" name="Encre 136">
@@ -13397,7 +13398,7 @@
               </p14:xfrm>
             </p:contentPart>
           </mc:Choice>
-          <mc:Fallback>
+          <mc:Fallback xmlns="">
             <p:pic>
               <p:nvPicPr>
                 <p:cNvPr id="137" name="Encre 136">
@@ -13428,8 +13429,8 @@
             </p:pic>
           </mc:Fallback>
         </mc:AlternateContent>
-        <mc:AlternateContent xmlns:mc="http://schemas.openxmlformats.org/markup-compatibility/2006">
-          <mc:Choice xmlns:p14="http://schemas.microsoft.com/office/powerpoint/2010/main" Requires="p14">
+        <mc:AlternateContent xmlns:mc="http://schemas.openxmlformats.org/markup-compatibility/2006" xmlns:p14="http://schemas.microsoft.com/office/powerpoint/2010/main">
+          <mc:Choice Requires="p14">
             <p:contentPart p14:bwMode="auto" r:id="rId220">
               <p14:nvContentPartPr>
                 <p14:cNvPr id="138" name="Encre 137">
@@ -13448,7 +13449,7 @@
               </p14:xfrm>
             </p:contentPart>
           </mc:Choice>
-          <mc:Fallback>
+          <mc:Fallback xmlns="">
             <p:pic>
               <p:nvPicPr>
                 <p:cNvPr id="138" name="Encre 137">
@@ -13479,8 +13480,8 @@
             </p:pic>
           </mc:Fallback>
         </mc:AlternateContent>
-        <mc:AlternateContent xmlns:mc="http://schemas.openxmlformats.org/markup-compatibility/2006">
-          <mc:Choice xmlns:p14="http://schemas.microsoft.com/office/powerpoint/2010/main" Requires="p14">
+        <mc:AlternateContent xmlns:mc="http://schemas.openxmlformats.org/markup-compatibility/2006" xmlns:p14="http://schemas.microsoft.com/office/powerpoint/2010/main">
+          <mc:Choice Requires="p14">
             <p:contentPart p14:bwMode="auto" r:id="rId222">
               <p14:nvContentPartPr>
                 <p14:cNvPr id="139" name="Encre 138">
@@ -13499,7 +13500,7 @@
               </p14:xfrm>
             </p:contentPart>
           </mc:Choice>
-          <mc:Fallback>
+          <mc:Fallback xmlns="">
             <p:pic>
               <p:nvPicPr>
                 <p:cNvPr id="139" name="Encre 138">
@@ -13551,8 +13552,8 @@
             <a:chExt cx="2901600" cy="872640"/>
           </a:xfrm>
         </p:grpSpPr>
-        <mc:AlternateContent xmlns:mc="http://schemas.openxmlformats.org/markup-compatibility/2006">
-          <mc:Choice xmlns:p14="http://schemas.microsoft.com/office/powerpoint/2010/main" Requires="p14">
+        <mc:AlternateContent xmlns:mc="http://schemas.openxmlformats.org/markup-compatibility/2006" xmlns:p14="http://schemas.microsoft.com/office/powerpoint/2010/main">
+          <mc:Choice Requires="p14">
             <p:contentPart p14:bwMode="auto" r:id="rId224">
               <p14:nvContentPartPr>
                 <p14:cNvPr id="141" name="Encre 140">
@@ -13571,7 +13572,7 @@
               </p14:xfrm>
             </p:contentPart>
           </mc:Choice>
-          <mc:Fallback>
+          <mc:Fallback xmlns="">
             <p:pic>
               <p:nvPicPr>
                 <p:cNvPr id="141" name="Encre 140">
@@ -13602,8 +13603,8 @@
             </p:pic>
           </mc:Fallback>
         </mc:AlternateContent>
-        <mc:AlternateContent xmlns:mc="http://schemas.openxmlformats.org/markup-compatibility/2006">
-          <mc:Choice xmlns:p14="http://schemas.microsoft.com/office/powerpoint/2010/main" Requires="p14">
+        <mc:AlternateContent xmlns:mc="http://schemas.openxmlformats.org/markup-compatibility/2006" xmlns:p14="http://schemas.microsoft.com/office/powerpoint/2010/main">
+          <mc:Choice Requires="p14">
             <p:contentPart p14:bwMode="auto" r:id="rId226">
               <p14:nvContentPartPr>
                 <p14:cNvPr id="142" name="Encre 141">
@@ -13622,7 +13623,7 @@
               </p14:xfrm>
             </p:contentPart>
           </mc:Choice>
-          <mc:Fallback>
+          <mc:Fallback xmlns="">
             <p:pic>
               <p:nvPicPr>
                 <p:cNvPr id="142" name="Encre 141">
@@ -13653,8 +13654,8 @@
             </p:pic>
           </mc:Fallback>
         </mc:AlternateContent>
-        <mc:AlternateContent xmlns:mc="http://schemas.openxmlformats.org/markup-compatibility/2006">
-          <mc:Choice xmlns:p14="http://schemas.microsoft.com/office/powerpoint/2010/main" Requires="p14">
+        <mc:AlternateContent xmlns:mc="http://schemas.openxmlformats.org/markup-compatibility/2006" xmlns:p14="http://schemas.microsoft.com/office/powerpoint/2010/main">
+          <mc:Choice Requires="p14">
             <p:contentPart p14:bwMode="auto" r:id="rId228">
               <p14:nvContentPartPr>
                 <p14:cNvPr id="143" name="Encre 142">
@@ -13673,7 +13674,7 @@
               </p14:xfrm>
             </p:contentPart>
           </mc:Choice>
-          <mc:Fallback>
+          <mc:Fallback xmlns="">
             <p:pic>
               <p:nvPicPr>
                 <p:cNvPr id="143" name="Encre 142">
@@ -13704,8 +13705,8 @@
             </p:pic>
           </mc:Fallback>
         </mc:AlternateContent>
-        <mc:AlternateContent xmlns:mc="http://schemas.openxmlformats.org/markup-compatibility/2006">
-          <mc:Choice xmlns:p14="http://schemas.microsoft.com/office/powerpoint/2010/main" Requires="p14">
+        <mc:AlternateContent xmlns:mc="http://schemas.openxmlformats.org/markup-compatibility/2006" xmlns:p14="http://schemas.microsoft.com/office/powerpoint/2010/main">
+          <mc:Choice Requires="p14">
             <p:contentPart p14:bwMode="auto" r:id="rId230">
               <p14:nvContentPartPr>
                 <p14:cNvPr id="145" name="Encre 144">
@@ -13724,7 +13725,7 @@
               </p14:xfrm>
             </p:contentPart>
           </mc:Choice>
-          <mc:Fallback>
+          <mc:Fallback xmlns="">
             <p:pic>
               <p:nvPicPr>
                 <p:cNvPr id="145" name="Encre 144">
@@ -13755,8 +13756,8 @@
             </p:pic>
           </mc:Fallback>
         </mc:AlternateContent>
-        <mc:AlternateContent xmlns:mc="http://schemas.openxmlformats.org/markup-compatibility/2006">
-          <mc:Choice xmlns:p14="http://schemas.microsoft.com/office/powerpoint/2010/main" Requires="p14">
+        <mc:AlternateContent xmlns:mc="http://schemas.openxmlformats.org/markup-compatibility/2006" xmlns:p14="http://schemas.microsoft.com/office/powerpoint/2010/main">
+          <mc:Choice Requires="p14">
             <p:contentPart p14:bwMode="auto" r:id="rId232">
               <p14:nvContentPartPr>
                 <p14:cNvPr id="146" name="Encre 145">
@@ -13775,7 +13776,7 @@
               </p14:xfrm>
             </p:contentPart>
           </mc:Choice>
-          <mc:Fallback>
+          <mc:Fallback xmlns="">
             <p:pic>
               <p:nvPicPr>
                 <p:cNvPr id="146" name="Encre 145">
@@ -13806,8 +13807,8 @@
             </p:pic>
           </mc:Fallback>
         </mc:AlternateContent>
-        <mc:AlternateContent xmlns:mc="http://schemas.openxmlformats.org/markup-compatibility/2006">
-          <mc:Choice xmlns:p14="http://schemas.microsoft.com/office/powerpoint/2010/main" Requires="p14">
+        <mc:AlternateContent xmlns:mc="http://schemas.openxmlformats.org/markup-compatibility/2006" xmlns:p14="http://schemas.microsoft.com/office/powerpoint/2010/main">
+          <mc:Choice Requires="p14">
             <p:contentPart p14:bwMode="auto" r:id="rId234">
               <p14:nvContentPartPr>
                 <p14:cNvPr id="147" name="Encre 146">
@@ -13826,7 +13827,7 @@
               </p14:xfrm>
             </p:contentPart>
           </mc:Choice>
-          <mc:Fallback>
+          <mc:Fallback xmlns="">
             <p:pic>
               <p:nvPicPr>
                 <p:cNvPr id="147" name="Encre 146">
@@ -13857,8 +13858,8 @@
             </p:pic>
           </mc:Fallback>
         </mc:AlternateContent>
-        <mc:AlternateContent xmlns:mc="http://schemas.openxmlformats.org/markup-compatibility/2006">
-          <mc:Choice xmlns:p14="http://schemas.microsoft.com/office/powerpoint/2010/main" Requires="p14">
+        <mc:AlternateContent xmlns:mc="http://schemas.openxmlformats.org/markup-compatibility/2006" xmlns:p14="http://schemas.microsoft.com/office/powerpoint/2010/main">
+          <mc:Choice Requires="p14">
             <p:contentPart p14:bwMode="auto" r:id="rId236">
               <p14:nvContentPartPr>
                 <p14:cNvPr id="148" name="Encre 147">
@@ -13877,7 +13878,7 @@
               </p14:xfrm>
             </p:contentPart>
           </mc:Choice>
-          <mc:Fallback>
+          <mc:Fallback xmlns="">
             <p:pic>
               <p:nvPicPr>
                 <p:cNvPr id="148" name="Encre 147">
@@ -15286,10 +15287,101 @@
           <a:chExt cx="0" cy="0"/>
         </a:xfrm>
       </p:grpSpPr>
+      <p:pic>
+        <p:nvPicPr>
+          <p:cNvPr id="3" name="Image 2">
+            <a:extLst>
+              <a:ext uri="{FF2B5EF4-FFF2-40B4-BE49-F238E27FC236}">
+                <a16:creationId xmlns:a16="http://schemas.microsoft.com/office/drawing/2014/main" id="{A5331968-AB08-3B4E-CA89-ED8CC4F2EC88}"/>
+              </a:ext>
+            </a:extLst>
+          </p:cNvPr>
+          <p:cNvPicPr>
+            <a:picLocks noChangeAspect="1"/>
+          </p:cNvPicPr>
+          <p:nvPr/>
+        </p:nvPicPr>
+        <p:blipFill>
+          <a:blip r:embed="rId2"/>
+          <a:srcRect b="23810"/>
+          <a:stretch>
+            <a:fillRect/>
+          </a:stretch>
+        </p:blipFill>
+        <p:spPr>
+          <a:xfrm>
+            <a:off x="0" y="86782"/>
+            <a:ext cx="12192000" cy="2271105"/>
+          </a:xfrm>
+          <a:prstGeom prst="rect">
+            <a:avLst/>
+          </a:prstGeom>
+        </p:spPr>
+      </p:pic>
     </p:spTree>
     <p:extLst>
       <p:ext uri="{BB962C8B-B14F-4D97-AF65-F5344CB8AC3E}">
         <p14:creationId xmlns:p14="http://schemas.microsoft.com/office/powerpoint/2010/main" val="827962784"/>
+      </p:ext>
+    </p:extLst>
+  </p:cSld>
+  <p:clrMapOvr>
+    <a:masterClrMapping/>
+  </p:clrMapOvr>
+</p:sld>
+</file>
+
+<file path=ppt/slides/slide9.xml><?xml version="1.0" encoding="utf-8"?>
+<p:sld xmlns:a="http://schemas.openxmlformats.org/drawingml/2006/main" xmlns:r="http://schemas.openxmlformats.org/officeDocument/2006/relationships" xmlns:p="http://schemas.openxmlformats.org/presentationml/2006/main">
+  <p:cSld>
+    <p:spTree>
+      <p:nvGrpSpPr>
+        <p:cNvPr id="1" name=""/>
+        <p:cNvGrpSpPr/>
+        <p:nvPr/>
+      </p:nvGrpSpPr>
+      <p:grpSpPr>
+        <a:xfrm>
+          <a:off x="0" y="0"/>
+          <a:ext cx="0" cy="0"/>
+          <a:chOff x="0" y="0"/>
+          <a:chExt cx="0" cy="0"/>
+        </a:xfrm>
+      </p:grpSpPr>
+      <p:pic>
+        <p:nvPicPr>
+          <p:cNvPr id="3" name="Image 2">
+            <a:extLst>
+              <a:ext uri="{FF2B5EF4-FFF2-40B4-BE49-F238E27FC236}">
+                <a16:creationId xmlns:a16="http://schemas.microsoft.com/office/drawing/2014/main" id="{648A5E20-60A0-D4A4-4558-00352EFB7D8C}"/>
+              </a:ext>
+            </a:extLst>
+          </p:cNvPr>
+          <p:cNvPicPr>
+            <a:picLocks noChangeAspect="1"/>
+          </p:cNvPicPr>
+          <p:nvPr/>
+        </p:nvPicPr>
+        <p:blipFill>
+          <a:blip r:embed="rId2"/>
+          <a:stretch>
+            <a:fillRect/>
+          </a:stretch>
+        </p:blipFill>
+        <p:spPr>
+          <a:xfrm>
+            <a:off x="0" y="43490"/>
+            <a:ext cx="12192000" cy="1238611"/>
+          </a:xfrm>
+          <a:prstGeom prst="rect">
+            <a:avLst/>
+          </a:prstGeom>
+        </p:spPr>
+      </p:pic>
+    </p:spTree>
+    <p:extLst>
+      <p:ext uri="{BB962C8B-B14F-4D97-AF65-F5344CB8AC3E}">
+        <p14:creationId xmlns:p14="http://schemas.microsoft.com/office/powerpoint/2010/main" val="3979187454"/>
       </p:ext>
     </p:extLst>
   </p:cSld>

</xml_diff>